<commit_message>
SSLC earn-out: reframe as single 5% rate + performance targets (Low $3M/Base $5M/High $6M+)
- Offer summary: replace 3%/5%/7% wording with target framing; add Earn-Out
  Targets FY27-31 table (tank + M1-M5 + stock + totals with check/dash marks);
  tighten to 2 pages
- Board deck slide 5: rebuild around 6-column targets table (Earn-out | Target |
  Low | Base | High | Pays) with per-year revenue targets and check/dash marks
- xlsx model Assumptions rows 23-25: change from rate inputs (0.03/0.05/0.07) to
  revenue target inputs ($3M/$5M/$6M); Total Compensation formulas updated to
  MIN(0.05*revTarget, cap); verified Low $150K/Base $250K/High $300K per yr
- build_sslc_option_b_model.py: same input changes applied (no regression)
- Totals verified: Low $950K / Base $2,525K / High $4,100K = III minus II
</commit_message>
<xml_diff>
--- a/drafts/Exos_SSLC_Board_Offer_Overview_2026-10-10.pptx
+++ b/drafts/Exos_SSLC_Board_Offer_Overview_2026-10-10.pptx
@@ -862,7 +862,7 @@
           <a:p>
             <a:r>
               <a:rPr lang="en-US" dirty="0"/>
-              <a:t>Tank earn-out: 5 years, 3%/5%/7% of IM revenue (Low/Base/High), $300K/yr cap. M1 pays FY28 Q1 if verified. M2 pays at contract execution any year FY27-30. M3 pays first year threshold hit (est. FY29 at base/high). M4 pays first year threshold hit (est. FY31 at high). M5 pays at Exos BLK3 tank certification (est. FY27-28). Stock earn-out: 0.0%/0.25%/0.50% additional FD equity at RTO, with the same lockup as Exos principals. Each milestone is independently verifiable; none pays unless the trigger is met.</a:t>
+              <a:t>Tank earn-out: single 5% rate applied to the revenue SSLC achieves each year FY27–FY31, capped at $300K/yr. Scenario = the annual IM tank revenue level: Low $3.0M/yr → $150K/yr → $750K total; Base $5.0M/yr → $250K/yr → $1.25M; High $6.0M+/yr → $300K/yr (cap) → $1.5M. M1 (L/B/H): FY27 rev ≥$5.1M → $200K, pays FY28 Q1. M2 (B/H): OTV contract → $200K. M3 (B/H): rev ≥$10M → $250K. M4 (H): rev ≥$20M → $250K. M5 (H): BLK3 qual → $200K. Stock (0/0.25/0.50%): $0/$625K/$1,500K at RTO listing. Total earn-outs: Low $950K / Base $2,525K / High $4,100K. Each equals ③ minus ②.</a:t>
             </a:r>
             <a:endParaRPr lang="en-US" dirty="0"/>
           </a:p>
@@ -3932,8 +3932,8 @@
         </p:nvSpPr>
         <p:spPr>
           <a:xfrm>
-            <a:off x="457200" y="274320"/>
-            <a:ext cx="8229600" cy="457200"/>
+            <a:off x="320040" y="128016"/>
+            <a:ext cx="8503920" cy="420624"/>
           </a:xfrm>
           <a:prstGeom prst="rect">
             <a:avLst/>
@@ -3949,7 +3949,7 @@
               <a:buNone/>
             </a:pPr>
             <a:r>
-              <a:rPr lang="en-US" sz="2200" b="1" dirty="0">
+              <a:rPr lang="en-US" sz="2000" b="1" dirty="0">
                 <a:solidFill>
                   <a:srgbClr val="FFFFFF"/>
                 </a:solidFill>
@@ -3957,9 +3957,9 @@
                 <a:ea typeface="Cambria" pitchFamily="34" charset="-122"/>
                 <a:cs typeface="Cambria" pitchFamily="34" charset="-120"/>
               </a:rPr>
-              <a:t>How Value Grows: Earn-Outs &amp; Milestones</a:t>
-            </a:r>
-            <a:endParaRPr lang="en-US" sz="2200" dirty="0"/>
+              <a:t>How Value Grows: Earn-Out Targets FY27–FY31</a:t>
+            </a:r>
+            <a:endParaRPr lang="en-US" sz="2000" dirty="0"/>
           </a:p>
         </p:txBody>
       </p:sp>
@@ -3971,7 +3971,7 @@
         </p:nvSpPr>
         <p:spPr>
           <a:xfrm>
-            <a:off x="457200" y="749808"/>
+            <a:off x="320040" y="566928"/>
             <a:ext cx="1371600" cy="36576"/>
           </a:xfrm>
           <a:prstGeom prst="rect">
@@ -3991,8 +3991,8 @@
         </p:nvSpPr>
         <p:spPr>
           <a:xfrm>
-            <a:off x="320040" y="914400"/>
-            <a:ext cx="3246120" cy="347472"/>
+            <a:off x="274320" y="640080"/>
+            <a:ext cx="2011680" cy="365760"/>
           </a:xfrm>
           <a:prstGeom prst="rect">
             <a:avLst/>
@@ -4016,8 +4016,8 @@
         </p:nvSpPr>
         <p:spPr>
           <a:xfrm>
-            <a:off x="365760" y="941832"/>
-            <a:ext cx="3154680" cy="274320"/>
+            <a:off x="320040" y="676656"/>
+            <a:ext cx="1938528" cy="310896"/>
           </a:xfrm>
           <a:prstGeom prst="rect">
             <a:avLst/>
@@ -4033,14 +4033,14 @@
               <a:buNone/>
             </a:pPr>
             <a:r>
-              <a:rPr lang="en-US" sz="1200" b="1" dirty="0">
+              <a:rPr lang="en-US" sz="1000" b="1" dirty="0">
                 <a:solidFill>
                   <a:srgbClr val="F26A21"/>
                 </a:solidFill>
               </a:rPr>
               <a:t>Earn-Out</a:t>
             </a:r>
-            <a:endParaRPr lang="en-US" sz="1200" dirty="0"/>
+            <a:endParaRPr lang="en-US" sz="1000" dirty="0"/>
           </a:p>
         </p:txBody>
       </p:sp>
@@ -4052,8 +4052,8 @@
         </p:nvSpPr>
         <p:spPr>
           <a:xfrm>
-            <a:off x="3657600" y="914400"/>
-            <a:ext cx="1463040" cy="347472"/>
+            <a:off x="2331720" y="640080"/>
+            <a:ext cx="1874520" cy="365760"/>
           </a:xfrm>
           <a:prstGeom prst="rect">
             <a:avLst/>
@@ -4077,31 +4077,31 @@
         </p:nvSpPr>
         <p:spPr>
           <a:xfrm>
-            <a:off x="3703320" y="941832"/>
-            <a:ext cx="1371600" cy="274320"/>
-          </a:xfrm>
-          <a:prstGeom prst="rect">
-            <a:avLst/>
-          </a:prstGeom>
-          <a:noFill/>
-          <a:ln/>
-        </p:spPr>
-        <p:txBody>
-          <a:bodyPr wrap="square" rtlCol="0" anchor="ctr"/>
-          <a:lstStyle/>
-          <a:p>
-            <a:pPr algn="ctr" indent="0" marL="0">
-              <a:buNone/>
-            </a:pPr>
-            <a:r>
-              <a:rPr lang="en-US" sz="1200" b="1" dirty="0">
+            <a:off x="2377440" y="676656"/>
+            <a:ext cx="1801368" cy="310896"/>
+          </a:xfrm>
+          <a:prstGeom prst="rect">
+            <a:avLst/>
+          </a:prstGeom>
+          <a:noFill/>
+          <a:ln/>
+        </p:spPr>
+        <p:txBody>
+          <a:bodyPr wrap="square" rtlCol="0" anchor="ctr"/>
+          <a:lstStyle/>
+          <a:p>
+            <a:pPr algn="l" indent="0" marL="0">
+              <a:buNone/>
+            </a:pPr>
+            <a:r>
+              <a:rPr lang="en-US" sz="1000" b="1" dirty="0">
                 <a:solidFill>
                   <a:srgbClr val="F26A21"/>
                 </a:solidFill>
               </a:rPr>
-              <a:t>Low</a:t>
-            </a:r>
-            <a:endParaRPr lang="en-US" sz="1200" dirty="0"/>
+              <a:t>Target SSLC Must Hit</a:t>
+            </a:r>
+            <a:endParaRPr lang="en-US" sz="1000" dirty="0"/>
           </a:p>
         </p:txBody>
       </p:sp>
@@ -4113,8 +4113,8 @@
         </p:nvSpPr>
         <p:spPr>
           <a:xfrm>
-            <a:off x="5257800" y="914400"/>
-            <a:ext cx="1417320" cy="347472"/>
+            <a:off x="4251960" y="640080"/>
+            <a:ext cx="1051560" cy="365760"/>
           </a:xfrm>
           <a:prstGeom prst="rect">
             <a:avLst/>
@@ -4138,8 +4138,8 @@
         </p:nvSpPr>
         <p:spPr>
           <a:xfrm>
-            <a:off x="5303520" y="941832"/>
-            <a:ext cx="1325880" cy="274320"/>
+            <a:off x="4297680" y="676656"/>
+            <a:ext cx="978408" cy="310896"/>
           </a:xfrm>
           <a:prstGeom prst="rect">
             <a:avLst/>
@@ -4155,14 +4155,14 @@
               <a:buNone/>
             </a:pPr>
             <a:r>
-              <a:rPr lang="en-US" sz="1200" b="1" dirty="0">
+              <a:rPr lang="en-US" sz="1000" b="1" dirty="0">
                 <a:solidFill>
                   <a:srgbClr val="F26A21"/>
                 </a:solidFill>
               </a:rPr>
-              <a:t>Base</a:t>
-            </a:r>
-            <a:endParaRPr lang="en-US" sz="1200" dirty="0"/>
+              <a:t>Low</a:t>
+            </a:r>
+            <a:endParaRPr lang="en-US" sz="1000" dirty="0"/>
           </a:p>
         </p:txBody>
       </p:sp>
@@ -4174,8 +4174,8 @@
         </p:nvSpPr>
         <p:spPr>
           <a:xfrm>
-            <a:off x="6720840" y="914400"/>
-            <a:ext cx="2103120" cy="347472"/>
+            <a:off x="5349240" y="640080"/>
+            <a:ext cx="1051560" cy="365760"/>
           </a:xfrm>
           <a:prstGeom prst="rect">
             <a:avLst/>
@@ -4199,8 +4199,8 @@
         </p:nvSpPr>
         <p:spPr>
           <a:xfrm>
-            <a:off x="6766560" y="941832"/>
-            <a:ext cx="2011680" cy="274320"/>
+            <a:off x="5394960" y="676656"/>
+            <a:ext cx="978408" cy="310896"/>
           </a:xfrm>
           <a:prstGeom prst="rect">
             <a:avLst/>
@@ -4216,14 +4216,14 @@
               <a:buNone/>
             </a:pPr>
             <a:r>
-              <a:rPr lang="en-US" sz="1200" b="1" dirty="0">
+              <a:rPr lang="en-US" sz="1000" b="1" dirty="0">
                 <a:solidFill>
                   <a:srgbClr val="F26A21"/>
                 </a:solidFill>
               </a:rPr>
-              <a:t>High</a:t>
-            </a:r>
-            <a:endParaRPr lang="en-US" sz="1200" dirty="0"/>
+              <a:t>Base</a:t>
+            </a:r>
+            <a:endParaRPr lang="en-US" sz="1000" dirty="0"/>
           </a:p>
         </p:txBody>
       </p:sp>
@@ -4235,8 +4235,130 @@
         </p:nvSpPr>
         <p:spPr>
           <a:xfrm>
-            <a:off x="320040" y="1307592"/>
-            <a:ext cx="3246120" cy="393192"/>
+            <a:off x="6446520" y="640080"/>
+            <a:ext cx="1051560" cy="365760"/>
+          </a:xfrm>
+          <a:prstGeom prst="rect">
+            <a:avLst/>
+          </a:prstGeom>
+          <a:solidFill>
+            <a:srgbClr val="2A1000"/>
+          </a:solidFill>
+          <a:ln w="12700">
+            <a:solidFill>
+              <a:srgbClr val="F26A21"/>
+            </a:solidFill>
+            <a:prstDash val="solid"/>
+          </a:ln>
+        </p:spPr>
+      </p:sp>
+      <p:sp>
+        <p:nvSpPr>
+          <p:cNvPr id="13" name="Text 11"/>
+          <p:cNvSpPr txBox="1"/>
+          <p:nvPr/>
+        </p:nvSpPr>
+        <p:spPr>
+          <a:xfrm>
+            <a:off x="6492240" y="676656"/>
+            <a:ext cx="978408" cy="310896"/>
+          </a:xfrm>
+          <a:prstGeom prst="rect">
+            <a:avLst/>
+          </a:prstGeom>
+          <a:noFill/>
+          <a:ln/>
+        </p:spPr>
+        <p:txBody>
+          <a:bodyPr wrap="square" rtlCol="0" anchor="ctr"/>
+          <a:lstStyle/>
+          <a:p>
+            <a:pPr algn="ctr" indent="0" marL="0">
+              <a:buNone/>
+            </a:pPr>
+            <a:r>
+              <a:rPr lang="en-US" sz="1000" b="1" dirty="0">
+                <a:solidFill>
+                  <a:srgbClr val="F26A21"/>
+                </a:solidFill>
+              </a:rPr>
+              <a:t>High</a:t>
+            </a:r>
+            <a:endParaRPr lang="en-US" sz="1000" dirty="0"/>
+          </a:p>
+        </p:txBody>
+      </p:sp>
+      <p:sp>
+        <p:nvSpPr>
+          <p:cNvPr id="14" name="Shape 12"/>
+          <p:cNvSpPr/>
+          <p:nvPr/>
+        </p:nvSpPr>
+        <p:spPr>
+          <a:xfrm>
+            <a:off x="7543800" y="640080"/>
+            <a:ext cx="1005840" cy="365760"/>
+          </a:xfrm>
+          <a:prstGeom prst="rect">
+            <a:avLst/>
+          </a:prstGeom>
+          <a:solidFill>
+            <a:srgbClr val="2A1000"/>
+          </a:solidFill>
+          <a:ln w="12700">
+            <a:solidFill>
+              <a:srgbClr val="F26A21"/>
+            </a:solidFill>
+            <a:prstDash val="solid"/>
+          </a:ln>
+        </p:spPr>
+      </p:sp>
+      <p:sp>
+        <p:nvSpPr>
+          <p:cNvPr id="15" name="Text 13"/>
+          <p:cNvSpPr txBox="1"/>
+          <p:nvPr/>
+        </p:nvSpPr>
+        <p:spPr>
+          <a:xfrm>
+            <a:off x="7589520" y="676656"/>
+            <a:ext cx="932688" cy="310896"/>
+          </a:xfrm>
+          <a:prstGeom prst="rect">
+            <a:avLst/>
+          </a:prstGeom>
+          <a:noFill/>
+          <a:ln/>
+        </p:spPr>
+        <p:txBody>
+          <a:bodyPr wrap="square" rtlCol="0" anchor="ctr"/>
+          <a:lstStyle/>
+          <a:p>
+            <a:pPr algn="ctr" indent="0" marL="0">
+              <a:buNone/>
+            </a:pPr>
+            <a:r>
+              <a:rPr lang="en-US" sz="1000" b="1" dirty="0">
+                <a:solidFill>
+                  <a:srgbClr val="F26A21"/>
+                </a:solidFill>
+              </a:rPr>
+              <a:t>Pays</a:t>
+            </a:r>
+            <a:endParaRPr lang="en-US" sz="1000" dirty="0"/>
+          </a:p>
+        </p:txBody>
+      </p:sp>
+      <p:sp>
+        <p:nvSpPr>
+          <p:cNvPr id="16" name="Shape 14"/>
+          <p:cNvSpPr/>
+          <p:nvPr/>
+        </p:nvSpPr>
+        <p:spPr>
+          <a:xfrm>
+            <a:off x="274320" y="1005840"/>
+            <a:ext cx="2011680" cy="548640"/>
           </a:xfrm>
           <a:prstGeom prst="rect">
             <a:avLst/>
@@ -4254,14 +4376,14 @@
       </p:sp>
       <p:sp>
         <p:nvSpPr>
-          <p:cNvPr id="13" name="Text 11"/>
-          <p:cNvSpPr txBox="1"/>
-          <p:nvPr/>
-        </p:nvSpPr>
-        <p:spPr>
-          <a:xfrm>
-            <a:off x="384048" y="1335024"/>
-            <a:ext cx="3154680" cy="338328"/>
+          <p:cNvPr id="17" name="Text 15"/>
+          <p:cNvSpPr txBox="1"/>
+          <p:nvPr/>
+        </p:nvSpPr>
+        <p:spPr>
+          <a:xfrm>
+            <a:off x="329184" y="1024128"/>
+            <a:ext cx="1920240" cy="512064"/>
           </a:xfrm>
           <a:prstGeom prst="rect">
             <a:avLst/>
@@ -4277,27 +4399,41 @@
               <a:buNone/>
             </a:pPr>
             <a:r>
-              <a:rPr lang="en-US" sz="1100" dirty="0">
+              <a:rPr lang="en-US" sz="900" dirty="0">
                 <a:solidFill>
                   <a:srgbClr val="CCCCCC"/>
                 </a:solidFill>
               </a:rPr>
-              <a:t>Tank earn-out (5 yrs, IM revenue)</a:t>
-            </a:r>
-            <a:endParaRPr lang="en-US" sz="1100" dirty="0"/>
-          </a:p>
-        </p:txBody>
-      </p:sp>
-      <p:sp>
-        <p:nvSpPr>
-          <p:cNvPr id="14" name="Shape 12"/>
+              <a:t>5% of IM tank revenue/yr</a:t>
+            </a:r>
+            <a:endParaRPr lang="en-US" sz="900" dirty="0"/>
+          </a:p>
+          <a:p>
+            <a:pPr algn="l" indent="0" marL="0">
+              <a:buNone/>
+            </a:pPr>
+            <a:r>
+              <a:rPr lang="en-US" sz="900" dirty="0">
+                <a:solidFill>
+                  <a:srgbClr val="CCCCCC"/>
+                </a:solidFill>
+              </a:rPr>
+              <a:t>cap $300K/yr, FY27–FY31</a:t>
+            </a:r>
+            <a:endParaRPr lang="en-US" sz="900" dirty="0"/>
+          </a:p>
+        </p:txBody>
+      </p:sp>
+      <p:sp>
+        <p:nvSpPr>
+          <p:cNvPr id="18" name="Shape 16"/>
           <p:cNvSpPr/>
           <p:nvPr/>
         </p:nvSpPr>
         <p:spPr>
           <a:xfrm>
-            <a:off x="3657600" y="1307592"/>
-            <a:ext cx="1463040" cy="393192"/>
+            <a:off x="2331720" y="1005840"/>
+            <a:ext cx="1874520" cy="548640"/>
           </a:xfrm>
           <a:prstGeom prst="rect">
             <a:avLst/>
@@ -4315,50 +4451,64 @@
       </p:sp>
       <p:sp>
         <p:nvSpPr>
-          <p:cNvPr id="15" name="Text 13"/>
-          <p:cNvSpPr txBox="1"/>
-          <p:nvPr/>
-        </p:nvSpPr>
-        <p:spPr>
-          <a:xfrm>
-            <a:off x="3721608" y="1335024"/>
-            <a:ext cx="1371600" cy="338328"/>
-          </a:xfrm>
-          <a:prstGeom prst="rect">
-            <a:avLst/>
-          </a:prstGeom>
-          <a:noFill/>
-          <a:ln/>
-        </p:spPr>
-        <p:txBody>
-          <a:bodyPr wrap="square" rtlCol="0" anchor="ctr"/>
-          <a:lstStyle/>
-          <a:p>
-            <a:pPr algn="ctr" indent="0" marL="0">
-              <a:buNone/>
-            </a:pPr>
-            <a:r>
-              <a:rPr lang="en-US" sz="1200" dirty="0">
-                <a:solidFill>
-                  <a:srgbClr val="FFFFFF"/>
-                </a:solidFill>
-              </a:rPr>
-              <a:t>$750K</a:t>
-            </a:r>
-            <a:endParaRPr lang="en-US" sz="1200" dirty="0"/>
-          </a:p>
-        </p:txBody>
-      </p:sp>
-      <p:sp>
-        <p:nvSpPr>
-          <p:cNvPr id="16" name="Shape 14"/>
+          <p:cNvPr id="19" name="Text 17"/>
+          <p:cNvSpPr txBox="1"/>
+          <p:nvPr/>
+        </p:nvSpPr>
+        <p:spPr>
+          <a:xfrm>
+            <a:off x="2386584" y="1024128"/>
+            <a:ext cx="1783080" cy="512064"/>
+          </a:xfrm>
+          <a:prstGeom prst="rect">
+            <a:avLst/>
+          </a:prstGeom>
+          <a:noFill/>
+          <a:ln/>
+        </p:spPr>
+        <p:txBody>
+          <a:bodyPr wrap="square" rtlCol="0" anchor="ctr"/>
+          <a:lstStyle/>
+          <a:p>
+            <a:pPr algn="l" indent="0" marL="0">
+              <a:buNone/>
+            </a:pPr>
+            <a:r>
+              <a:rPr lang="en-US" sz="900" dirty="0">
+                <a:solidFill>
+                  <a:srgbClr val="CCCCCC"/>
+                </a:solidFill>
+              </a:rPr>
+              <a:t>Revenue SSLC achieves</a:t>
+            </a:r>
+            <a:endParaRPr lang="en-US" sz="900" dirty="0"/>
+          </a:p>
+          <a:p>
+            <a:pPr algn="l" indent="0" marL="0">
+              <a:buNone/>
+            </a:pPr>
+            <a:r>
+              <a:rPr lang="en-US" sz="900" dirty="0">
+                <a:solidFill>
+                  <a:srgbClr val="CCCCCC"/>
+                </a:solidFill>
+              </a:rPr>
+              <a:t>each year FY27–FY31</a:t>
+            </a:r>
+            <a:endParaRPr lang="en-US" sz="900" dirty="0"/>
+          </a:p>
+        </p:txBody>
+      </p:sp>
+      <p:sp>
+        <p:nvSpPr>
+          <p:cNvPr id="20" name="Shape 18"/>
           <p:cNvSpPr/>
           <p:nvPr/>
         </p:nvSpPr>
         <p:spPr>
           <a:xfrm>
-            <a:off x="5257800" y="1307592"/>
-            <a:ext cx="1417320" cy="393192"/>
+            <a:off x="4251960" y="1005840"/>
+            <a:ext cx="1051560" cy="548640"/>
           </a:xfrm>
           <a:prstGeom prst="rect">
             <a:avLst/>
@@ -4376,14 +4526,14 @@
       </p:sp>
       <p:sp>
         <p:nvSpPr>
-          <p:cNvPr id="17" name="Text 15"/>
-          <p:cNvSpPr txBox="1"/>
-          <p:nvPr/>
-        </p:nvSpPr>
-        <p:spPr>
-          <a:xfrm>
-            <a:off x="5321808" y="1335024"/>
-            <a:ext cx="1325880" cy="338328"/>
+          <p:cNvPr id="21" name="Text 19"/>
+          <p:cNvSpPr txBox="1"/>
+          <p:nvPr/>
+        </p:nvSpPr>
+        <p:spPr>
+          <a:xfrm>
+            <a:off x="4306824" y="1024128"/>
+            <a:ext cx="960120" cy="512064"/>
           </a:xfrm>
           <a:prstGeom prst="rect">
             <a:avLst/>
@@ -4399,27 +4549,55 @@
               <a:buNone/>
             </a:pPr>
             <a:r>
-              <a:rPr lang="en-US" sz="1200" dirty="0">
-                <a:solidFill>
-                  <a:srgbClr val="FFFFFF"/>
-                </a:solidFill>
-              </a:rPr>
-              <a:t>$1,250K</a:t>
-            </a:r>
-            <a:endParaRPr lang="en-US" sz="1200" dirty="0"/>
-          </a:p>
-        </p:txBody>
-      </p:sp>
-      <p:sp>
-        <p:nvSpPr>
-          <p:cNvPr id="18" name="Shape 16"/>
+              <a:rPr lang="en-US" sz="900" dirty="0">
+                <a:solidFill>
+                  <a:srgbClr val="F26A21"/>
+                </a:solidFill>
+              </a:rPr>
+              <a:t>$3.0M/yr</a:t>
+            </a:r>
+            <a:endParaRPr lang="en-US" sz="900" dirty="0"/>
+          </a:p>
+          <a:p>
+            <a:pPr algn="ctr" indent="0" marL="0">
+              <a:buNone/>
+            </a:pPr>
+            <a:r>
+              <a:rPr lang="en-US" sz="900" dirty="0">
+                <a:solidFill>
+                  <a:srgbClr val="F26A21"/>
+                </a:solidFill>
+              </a:rPr>
+              <a:t>→$150K/yr</a:t>
+            </a:r>
+            <a:endParaRPr lang="en-US" sz="900" dirty="0"/>
+          </a:p>
+          <a:p>
+            <a:pPr algn="ctr" indent="0" marL="0">
+              <a:buNone/>
+            </a:pPr>
+            <a:r>
+              <a:rPr lang="en-US" sz="900" dirty="0">
+                <a:solidFill>
+                  <a:srgbClr val="F26A21"/>
+                </a:solidFill>
+              </a:rPr>
+              <a:t>→$750K total</a:t>
+            </a:r>
+            <a:endParaRPr lang="en-US" sz="900" dirty="0"/>
+          </a:p>
+        </p:txBody>
+      </p:sp>
+      <p:sp>
+        <p:nvSpPr>
+          <p:cNvPr id="22" name="Shape 20"/>
           <p:cNvSpPr/>
           <p:nvPr/>
         </p:nvSpPr>
         <p:spPr>
           <a:xfrm>
-            <a:off x="6720840" y="1307592"/>
-            <a:ext cx="2103120" cy="393192"/>
+            <a:off x="5349240" y="1005840"/>
+            <a:ext cx="1051560" cy="548640"/>
           </a:xfrm>
           <a:prstGeom prst="rect">
             <a:avLst/>
@@ -4437,14 +4615,14 @@
       </p:sp>
       <p:sp>
         <p:nvSpPr>
-          <p:cNvPr id="19" name="Text 17"/>
-          <p:cNvSpPr txBox="1"/>
-          <p:nvPr/>
-        </p:nvSpPr>
-        <p:spPr>
-          <a:xfrm>
-            <a:off x="6784848" y="1335024"/>
-            <a:ext cx="2011680" cy="338328"/>
+          <p:cNvPr id="23" name="Text 21"/>
+          <p:cNvSpPr txBox="1"/>
+          <p:nvPr/>
+        </p:nvSpPr>
+        <p:spPr>
+          <a:xfrm>
+            <a:off x="5404104" y="1024128"/>
+            <a:ext cx="960120" cy="512064"/>
           </a:xfrm>
           <a:prstGeom prst="rect">
             <a:avLst/>
@@ -4460,33 +4638,61 @@
               <a:buNone/>
             </a:pPr>
             <a:r>
-              <a:rPr lang="en-US" sz="1200" dirty="0">
-                <a:solidFill>
-                  <a:srgbClr val="FFFFFF"/>
-                </a:solidFill>
-              </a:rPr>
-              <a:t>$1,500K</a:t>
-            </a:r>
-            <a:endParaRPr lang="en-US" sz="1200" dirty="0"/>
-          </a:p>
-        </p:txBody>
-      </p:sp>
-      <p:sp>
-        <p:nvSpPr>
-          <p:cNvPr id="20" name="Shape 18"/>
+              <a:rPr lang="en-US" sz="900" dirty="0">
+                <a:solidFill>
+                  <a:srgbClr val="F26A21"/>
+                </a:solidFill>
+              </a:rPr>
+              <a:t>$5.0M/yr</a:t>
+            </a:r>
+            <a:endParaRPr lang="en-US" sz="900" dirty="0"/>
+          </a:p>
+          <a:p>
+            <a:pPr algn="ctr" indent="0" marL="0">
+              <a:buNone/>
+            </a:pPr>
+            <a:r>
+              <a:rPr lang="en-US" sz="900" dirty="0">
+                <a:solidFill>
+                  <a:srgbClr val="F26A21"/>
+                </a:solidFill>
+              </a:rPr>
+              <a:t>→$250K/yr</a:t>
+            </a:r>
+            <a:endParaRPr lang="en-US" sz="900" dirty="0"/>
+          </a:p>
+          <a:p>
+            <a:pPr algn="ctr" indent="0" marL="0">
+              <a:buNone/>
+            </a:pPr>
+            <a:r>
+              <a:rPr lang="en-US" sz="900" dirty="0">
+                <a:solidFill>
+                  <a:srgbClr val="F26A21"/>
+                </a:solidFill>
+              </a:rPr>
+              <a:t>→$1.25M total</a:t>
+            </a:r>
+            <a:endParaRPr lang="en-US" sz="900" dirty="0"/>
+          </a:p>
+        </p:txBody>
+      </p:sp>
+      <p:sp>
+        <p:nvSpPr>
+          <p:cNvPr id="24" name="Shape 22"/>
           <p:cNvSpPr/>
           <p:nvPr/>
         </p:nvSpPr>
         <p:spPr>
           <a:xfrm>
-            <a:off x="320040" y="1728216"/>
-            <a:ext cx="3246120" cy="393192"/>
-          </a:xfrm>
-          <a:prstGeom prst="rect">
-            <a:avLst/>
-          </a:prstGeom>
-          <a:solidFill>
-            <a:srgbClr val="222222"/>
+            <a:off x="6446520" y="1005840"/>
+            <a:ext cx="1051560" cy="548640"/>
+          </a:xfrm>
+          <a:prstGeom prst="rect">
+            <a:avLst/>
+          </a:prstGeom>
+          <a:solidFill>
+            <a:srgbClr val="1C1C1C"/>
           </a:solidFill>
           <a:ln w="12700">
             <a:solidFill>
@@ -4498,56 +4704,84 @@
       </p:sp>
       <p:sp>
         <p:nvSpPr>
-          <p:cNvPr id="21" name="Text 19"/>
-          <p:cNvSpPr txBox="1"/>
-          <p:nvPr/>
-        </p:nvSpPr>
-        <p:spPr>
-          <a:xfrm>
-            <a:off x="384048" y="1755648"/>
-            <a:ext cx="3154680" cy="338328"/>
-          </a:xfrm>
-          <a:prstGeom prst="rect">
-            <a:avLst/>
-          </a:prstGeom>
-          <a:noFill/>
-          <a:ln/>
-        </p:spPr>
-        <p:txBody>
-          <a:bodyPr wrap="square" rtlCol="0" anchor="ctr"/>
-          <a:lstStyle/>
-          <a:p>
-            <a:pPr algn="l" indent="0" marL="0">
-              <a:buNone/>
-            </a:pPr>
-            <a:r>
-              <a:rPr lang="en-US" sz="1100" dirty="0">
-                <a:solidFill>
-                  <a:srgbClr val="CCCCCC"/>
-                </a:solidFill>
-              </a:rPr>
-              <a:t>M1: FY2026-27 revenue ≥ $5.1M</a:t>
-            </a:r>
-            <a:endParaRPr lang="en-US" sz="1100" dirty="0"/>
-          </a:p>
-        </p:txBody>
-      </p:sp>
-      <p:sp>
-        <p:nvSpPr>
-          <p:cNvPr id="22" name="Shape 20"/>
+          <p:cNvPr id="25" name="Text 23"/>
+          <p:cNvSpPr txBox="1"/>
+          <p:nvPr/>
+        </p:nvSpPr>
+        <p:spPr>
+          <a:xfrm>
+            <a:off x="6501384" y="1024128"/>
+            <a:ext cx="960120" cy="512064"/>
+          </a:xfrm>
+          <a:prstGeom prst="rect">
+            <a:avLst/>
+          </a:prstGeom>
+          <a:noFill/>
+          <a:ln/>
+        </p:spPr>
+        <p:txBody>
+          <a:bodyPr wrap="square" rtlCol="0" anchor="ctr"/>
+          <a:lstStyle/>
+          <a:p>
+            <a:pPr algn="ctr" indent="0" marL="0">
+              <a:buNone/>
+            </a:pPr>
+            <a:r>
+              <a:rPr lang="en-US" sz="900" dirty="0">
+                <a:solidFill>
+                  <a:srgbClr val="F26A21"/>
+                </a:solidFill>
+              </a:rPr>
+              <a:t>$6.0M+/yr</a:t>
+            </a:r>
+            <a:endParaRPr lang="en-US" sz="900" dirty="0"/>
+          </a:p>
+          <a:p>
+            <a:pPr algn="ctr" indent="0" marL="0">
+              <a:buNone/>
+            </a:pPr>
+            <a:r>
+              <a:rPr lang="en-US" sz="900" dirty="0">
+                <a:solidFill>
+                  <a:srgbClr val="F26A21"/>
+                </a:solidFill>
+              </a:rPr>
+              <a:t>→$300K/yr (cap)</a:t>
+            </a:r>
+            <a:endParaRPr lang="en-US" sz="900" dirty="0"/>
+          </a:p>
+          <a:p>
+            <a:pPr algn="ctr" indent="0" marL="0">
+              <a:buNone/>
+            </a:pPr>
+            <a:r>
+              <a:rPr lang="en-US" sz="900" dirty="0">
+                <a:solidFill>
+                  <a:srgbClr val="F26A21"/>
+                </a:solidFill>
+              </a:rPr>
+              <a:t>→$1.5M total</a:t>
+            </a:r>
+            <a:endParaRPr lang="en-US" sz="900" dirty="0"/>
+          </a:p>
+        </p:txBody>
+      </p:sp>
+      <p:sp>
+        <p:nvSpPr>
+          <p:cNvPr id="26" name="Shape 24"/>
           <p:cNvSpPr/>
           <p:nvPr/>
         </p:nvSpPr>
         <p:spPr>
           <a:xfrm>
-            <a:off x="3657600" y="1728216"/>
-            <a:ext cx="1463040" cy="393192"/>
-          </a:xfrm>
-          <a:prstGeom prst="rect">
-            <a:avLst/>
-          </a:prstGeom>
-          <a:solidFill>
-            <a:srgbClr val="222222"/>
+            <a:off x="7543800" y="1005840"/>
+            <a:ext cx="1005840" cy="548640"/>
+          </a:xfrm>
+          <a:prstGeom prst="rect">
+            <a:avLst/>
+          </a:prstGeom>
+          <a:solidFill>
+            <a:srgbClr val="1C1C1C"/>
           </a:solidFill>
           <a:ln w="12700">
             <a:solidFill>
@@ -4559,14 +4793,14 @@
       </p:sp>
       <p:sp>
         <p:nvSpPr>
-          <p:cNvPr id="23" name="Text 21"/>
-          <p:cNvSpPr txBox="1"/>
-          <p:nvPr/>
-        </p:nvSpPr>
-        <p:spPr>
-          <a:xfrm>
-            <a:off x="3721608" y="1755648"/>
-            <a:ext cx="1371600" cy="338328"/>
+          <p:cNvPr id="27" name="Text 25"/>
+          <p:cNvSpPr txBox="1"/>
+          <p:nvPr/>
+        </p:nvSpPr>
+        <p:spPr>
+          <a:xfrm>
+            <a:off x="7598664" y="1024128"/>
+            <a:ext cx="914400" cy="512064"/>
           </a:xfrm>
           <a:prstGeom prst="rect">
             <a:avLst/>
@@ -4582,33 +4816,47 @@
               <a:buNone/>
             </a:pPr>
             <a:r>
-              <a:rPr lang="en-US" sz="1200" dirty="0">
-                <a:solidFill>
-                  <a:srgbClr val="FFFFFF"/>
-                </a:solidFill>
-              </a:rPr>
-              <a:t>$200K</a:t>
-            </a:r>
-            <a:endParaRPr lang="en-US" sz="1200" dirty="0"/>
-          </a:p>
-        </p:txBody>
-      </p:sp>
-      <p:sp>
-        <p:nvSpPr>
-          <p:cNvPr id="24" name="Shape 22"/>
+              <a:rPr lang="en-US" sz="900" dirty="0">
+                <a:solidFill>
+                  <a:srgbClr val="F26A21"/>
+                </a:solidFill>
+              </a:rPr>
+              <a:t>Annual</a:t>
+            </a:r>
+            <a:endParaRPr lang="en-US" sz="900" dirty="0"/>
+          </a:p>
+          <a:p>
+            <a:pPr algn="ctr" indent="0" marL="0">
+              <a:buNone/>
+            </a:pPr>
+            <a:r>
+              <a:rPr lang="en-US" sz="900" dirty="0">
+                <a:solidFill>
+                  <a:srgbClr val="F26A21"/>
+                </a:solidFill>
+              </a:rPr>
+              <a:t>FY27–FY31</a:t>
+            </a:r>
+            <a:endParaRPr lang="en-US" sz="900" dirty="0"/>
+          </a:p>
+        </p:txBody>
+      </p:sp>
+      <p:sp>
+        <p:nvSpPr>
+          <p:cNvPr id="28" name="Shape 26"/>
           <p:cNvSpPr/>
           <p:nvPr/>
         </p:nvSpPr>
         <p:spPr>
           <a:xfrm>
-            <a:off x="5257800" y="1728216"/>
-            <a:ext cx="1417320" cy="393192"/>
-          </a:xfrm>
-          <a:prstGeom prst="rect">
-            <a:avLst/>
-          </a:prstGeom>
-          <a:solidFill>
-            <a:srgbClr val="222222"/>
+            <a:off x="274320" y="1554480"/>
+            <a:ext cx="2011680" cy="365760"/>
+          </a:xfrm>
+          <a:prstGeom prst="rect">
+            <a:avLst/>
+          </a:prstGeom>
+          <a:solidFill>
+            <a:srgbClr val="1A2035"/>
           </a:solidFill>
           <a:ln w="12700">
             <a:solidFill>
@@ -4620,56 +4868,56 @@
       </p:sp>
       <p:sp>
         <p:nvSpPr>
-          <p:cNvPr id="25" name="Text 23"/>
-          <p:cNvSpPr txBox="1"/>
-          <p:nvPr/>
-        </p:nvSpPr>
-        <p:spPr>
-          <a:xfrm>
-            <a:off x="5321808" y="1755648"/>
-            <a:ext cx="1325880" cy="338328"/>
-          </a:xfrm>
-          <a:prstGeom prst="rect">
-            <a:avLst/>
-          </a:prstGeom>
-          <a:noFill/>
-          <a:ln/>
-        </p:spPr>
-        <p:txBody>
-          <a:bodyPr wrap="square" rtlCol="0" anchor="ctr"/>
-          <a:lstStyle/>
-          <a:p>
-            <a:pPr algn="ctr" indent="0" marL="0">
-              <a:buNone/>
-            </a:pPr>
-            <a:r>
-              <a:rPr lang="en-US" sz="1200" dirty="0">
-                <a:solidFill>
-                  <a:srgbClr val="FFFFFF"/>
-                </a:solidFill>
-              </a:rPr>
-              <a:t>$200K</a:t>
-            </a:r>
-            <a:endParaRPr lang="en-US" sz="1200" dirty="0"/>
-          </a:p>
-        </p:txBody>
-      </p:sp>
-      <p:sp>
-        <p:nvSpPr>
-          <p:cNvPr id="26" name="Shape 24"/>
+          <p:cNvPr id="29" name="Text 27"/>
+          <p:cNvSpPr txBox="1"/>
+          <p:nvPr/>
+        </p:nvSpPr>
+        <p:spPr>
+          <a:xfrm>
+            <a:off x="329184" y="1572768"/>
+            <a:ext cx="1920240" cy="329184"/>
+          </a:xfrm>
+          <a:prstGeom prst="rect">
+            <a:avLst/>
+          </a:prstGeom>
+          <a:noFill/>
+          <a:ln/>
+        </p:spPr>
+        <p:txBody>
+          <a:bodyPr wrap="square" rtlCol="0" anchor="ctr"/>
+          <a:lstStyle/>
+          <a:p>
+            <a:pPr algn="l" indent="0" marL="0">
+              <a:buNone/>
+            </a:pPr>
+            <a:r>
+              <a:rPr lang="en-US" sz="900" dirty="0">
+                <a:solidFill>
+                  <a:srgbClr val="CCCCCC"/>
+                </a:solidFill>
+              </a:rPr>
+              <a:t>M1  SSLC FY27 rev ≥$5.1M  →$200K</a:t>
+            </a:r>
+            <a:endParaRPr lang="en-US" sz="900" dirty="0"/>
+          </a:p>
+        </p:txBody>
+      </p:sp>
+      <p:sp>
+        <p:nvSpPr>
+          <p:cNvPr id="30" name="Shape 28"/>
           <p:cNvSpPr/>
           <p:nvPr/>
         </p:nvSpPr>
         <p:spPr>
           <a:xfrm>
-            <a:off x="6720840" y="1728216"/>
-            <a:ext cx="2103120" cy="393192"/>
-          </a:xfrm>
-          <a:prstGeom prst="rect">
-            <a:avLst/>
-          </a:prstGeom>
-          <a:solidFill>
-            <a:srgbClr val="222222"/>
+            <a:off x="2331720" y="1554480"/>
+            <a:ext cx="1874520" cy="365760"/>
+          </a:xfrm>
+          <a:prstGeom prst="rect">
+            <a:avLst/>
+          </a:prstGeom>
+          <a:solidFill>
+            <a:srgbClr val="1A2035"/>
           </a:solidFill>
           <a:ln w="12700">
             <a:solidFill>
@@ -4681,56 +4929,56 @@
       </p:sp>
       <p:sp>
         <p:nvSpPr>
-          <p:cNvPr id="27" name="Text 25"/>
-          <p:cNvSpPr txBox="1"/>
-          <p:nvPr/>
-        </p:nvSpPr>
-        <p:spPr>
-          <a:xfrm>
-            <a:off x="6784848" y="1755648"/>
-            <a:ext cx="2011680" cy="338328"/>
-          </a:xfrm>
-          <a:prstGeom prst="rect">
-            <a:avLst/>
-          </a:prstGeom>
-          <a:noFill/>
-          <a:ln/>
-        </p:spPr>
-        <p:txBody>
-          <a:bodyPr wrap="square" rtlCol="0" anchor="ctr"/>
-          <a:lstStyle/>
-          <a:p>
-            <a:pPr algn="ctr" indent="0" marL="0">
-              <a:buNone/>
-            </a:pPr>
-            <a:r>
-              <a:rPr lang="en-US" sz="1200" dirty="0">
-                <a:solidFill>
-                  <a:srgbClr val="FFFFFF"/>
-                </a:solidFill>
-              </a:rPr>
-              <a:t>$200K</a:t>
-            </a:r>
-            <a:endParaRPr lang="en-US" sz="1200" dirty="0"/>
-          </a:p>
-        </p:txBody>
-      </p:sp>
-      <p:sp>
-        <p:nvSpPr>
-          <p:cNvPr id="28" name="Shape 26"/>
+          <p:cNvPr id="31" name="Text 29"/>
+          <p:cNvSpPr txBox="1"/>
+          <p:nvPr/>
+        </p:nvSpPr>
+        <p:spPr>
+          <a:xfrm>
+            <a:off x="2386584" y="1572768"/>
+            <a:ext cx="1783080" cy="329184"/>
+          </a:xfrm>
+          <a:prstGeom prst="rect">
+            <a:avLst/>
+          </a:prstGeom>
+          <a:noFill/>
+          <a:ln/>
+        </p:spPr>
+        <p:txBody>
+          <a:bodyPr wrap="square" rtlCol="0" anchor="ctr"/>
+          <a:lstStyle/>
+          <a:p>
+            <a:pPr algn="l" indent="0" marL="0">
+              <a:buNone/>
+            </a:pPr>
+            <a:r>
+              <a:rPr lang="en-US" sz="900" dirty="0">
+                <a:solidFill>
+                  <a:srgbClr val="CCCCCC"/>
+                </a:solidFill>
+              </a:rPr>
+              <a:t>Annual rev ≥$5.1M in FY27</a:t>
+            </a:r>
+            <a:endParaRPr lang="en-US" sz="900" dirty="0"/>
+          </a:p>
+        </p:txBody>
+      </p:sp>
+      <p:sp>
+        <p:nvSpPr>
+          <p:cNvPr id="32" name="Shape 30"/>
           <p:cNvSpPr/>
           <p:nvPr/>
         </p:nvSpPr>
         <p:spPr>
           <a:xfrm>
-            <a:off x="320040" y="2148840"/>
-            <a:ext cx="3246120" cy="393192"/>
-          </a:xfrm>
-          <a:prstGeom prst="rect">
-            <a:avLst/>
-          </a:prstGeom>
-          <a:solidFill>
-            <a:srgbClr val="1C1C1C"/>
+            <a:off x="4251960" y="1554480"/>
+            <a:ext cx="1051560" cy="365760"/>
+          </a:xfrm>
+          <a:prstGeom prst="rect">
+            <a:avLst/>
+          </a:prstGeom>
+          <a:solidFill>
+            <a:srgbClr val="1A2035"/>
           </a:solidFill>
           <a:ln w="12700">
             <a:solidFill>
@@ -4742,35 +4990,35 @@
       </p:sp>
       <p:sp>
         <p:nvSpPr>
-          <p:cNvPr id="29" name="Text 27"/>
-          <p:cNvSpPr txBox="1"/>
-          <p:nvPr/>
-        </p:nvSpPr>
-        <p:spPr>
-          <a:xfrm>
-            <a:off x="384048" y="2176272"/>
-            <a:ext cx="3154680" cy="338328"/>
-          </a:xfrm>
-          <a:prstGeom prst="rect">
-            <a:avLst/>
-          </a:prstGeom>
-          <a:noFill/>
-          <a:ln/>
-        </p:spPr>
-        <p:txBody>
-          <a:bodyPr wrap="square" rtlCol="0" anchor="ctr"/>
-          <a:lstStyle/>
-          <a:p>
-            <a:pPr algn="l" indent="0" marL="0">
+          <p:cNvPr id="33" name="Text 31"/>
+          <p:cNvSpPr txBox="1"/>
+          <p:nvPr/>
+        </p:nvSpPr>
+        <p:spPr>
+          <a:xfrm>
+            <a:off x="4306824" y="1572768"/>
+            <a:ext cx="960120" cy="329184"/>
+          </a:xfrm>
+          <a:prstGeom prst="rect">
+            <a:avLst/>
+          </a:prstGeom>
+          <a:noFill/>
+          <a:ln/>
+        </p:spPr>
+        <p:txBody>
+          <a:bodyPr wrap="square" rtlCol="0" anchor="ctr"/>
+          <a:lstStyle/>
+          <a:p>
+            <a:pPr algn="ctr" indent="0" marL="0">
               <a:buNone/>
             </a:pPr>
             <a:r>
               <a:rPr lang="en-US" sz="1100" dirty="0">
                 <a:solidFill>
-                  <a:srgbClr val="CCCCCC"/>
-                </a:solidFill>
-              </a:rPr>
-              <a:t>M2: Nebula/OTV production contract signed</a:t>
+                  <a:srgbClr val="2ECC71"/>
+                </a:solidFill>
+              </a:rPr>
+              <a:t>✓</a:t>
             </a:r>
             <a:endParaRPr lang="en-US" sz="1100" dirty="0"/>
           </a:p>
@@ -4778,20 +5026,20 @@
       </p:sp>
       <p:sp>
         <p:nvSpPr>
-          <p:cNvPr id="30" name="Shape 28"/>
+          <p:cNvPr id="34" name="Shape 32"/>
           <p:cNvSpPr/>
           <p:nvPr/>
         </p:nvSpPr>
         <p:spPr>
           <a:xfrm>
-            <a:off x="3657600" y="2148840"/>
-            <a:ext cx="1463040" cy="393192"/>
-          </a:xfrm>
-          <a:prstGeom prst="rect">
-            <a:avLst/>
-          </a:prstGeom>
-          <a:solidFill>
-            <a:srgbClr val="1C1C1C"/>
+            <a:off x="5349240" y="1554480"/>
+            <a:ext cx="1051560" cy="365760"/>
+          </a:xfrm>
+          <a:prstGeom prst="rect">
+            <a:avLst/>
+          </a:prstGeom>
+          <a:solidFill>
+            <a:srgbClr val="1A2035"/>
           </a:solidFill>
           <a:ln w="12700">
             <a:solidFill>
@@ -4803,14 +5051,14 @@
       </p:sp>
       <p:sp>
         <p:nvSpPr>
-          <p:cNvPr id="31" name="Text 29"/>
-          <p:cNvSpPr txBox="1"/>
-          <p:nvPr/>
-        </p:nvSpPr>
-        <p:spPr>
-          <a:xfrm>
-            <a:off x="3721608" y="2176272"/>
-            <a:ext cx="1371600" cy="338328"/>
+          <p:cNvPr id="35" name="Text 33"/>
+          <p:cNvSpPr txBox="1"/>
+          <p:nvPr/>
+        </p:nvSpPr>
+        <p:spPr>
+          <a:xfrm>
+            <a:off x="5404104" y="1572768"/>
+            <a:ext cx="960120" cy="329184"/>
           </a:xfrm>
           <a:prstGeom prst="rect">
             <a:avLst/>
@@ -4826,33 +5074,33 @@
               <a:buNone/>
             </a:pPr>
             <a:r>
-              <a:rPr lang="en-US" sz="1200" dirty="0">
-                <a:solidFill>
-                  <a:srgbClr val="888888"/>
-                </a:solidFill>
-              </a:rPr>
-              <a:t>—</a:t>
-            </a:r>
-            <a:endParaRPr lang="en-US" sz="1200" dirty="0"/>
-          </a:p>
-        </p:txBody>
-      </p:sp>
-      <p:sp>
-        <p:nvSpPr>
-          <p:cNvPr id="32" name="Shape 30"/>
+              <a:rPr lang="en-US" sz="1100" dirty="0">
+                <a:solidFill>
+                  <a:srgbClr val="2ECC71"/>
+                </a:solidFill>
+              </a:rPr>
+              <a:t>✓</a:t>
+            </a:r>
+            <a:endParaRPr lang="en-US" sz="1100" dirty="0"/>
+          </a:p>
+        </p:txBody>
+      </p:sp>
+      <p:sp>
+        <p:nvSpPr>
+          <p:cNvPr id="36" name="Shape 34"/>
           <p:cNvSpPr/>
           <p:nvPr/>
         </p:nvSpPr>
         <p:spPr>
           <a:xfrm>
-            <a:off x="5257800" y="2148840"/>
-            <a:ext cx="1417320" cy="393192"/>
-          </a:xfrm>
-          <a:prstGeom prst="rect">
-            <a:avLst/>
-          </a:prstGeom>
-          <a:solidFill>
-            <a:srgbClr val="1C1C1C"/>
+            <a:off x="6446520" y="1554480"/>
+            <a:ext cx="1051560" cy="365760"/>
+          </a:xfrm>
+          <a:prstGeom prst="rect">
+            <a:avLst/>
+          </a:prstGeom>
+          <a:solidFill>
+            <a:srgbClr val="1A2035"/>
           </a:solidFill>
           <a:ln w="12700">
             <a:solidFill>
@@ -4864,14 +5112,14 @@
       </p:sp>
       <p:sp>
         <p:nvSpPr>
-          <p:cNvPr id="33" name="Text 31"/>
-          <p:cNvSpPr txBox="1"/>
-          <p:nvPr/>
-        </p:nvSpPr>
-        <p:spPr>
-          <a:xfrm>
-            <a:off x="5321808" y="2176272"/>
-            <a:ext cx="1325880" cy="338328"/>
+          <p:cNvPr id="37" name="Text 35"/>
+          <p:cNvSpPr txBox="1"/>
+          <p:nvPr/>
+        </p:nvSpPr>
+        <p:spPr>
+          <a:xfrm>
+            <a:off x="6501384" y="1572768"/>
+            <a:ext cx="960120" cy="329184"/>
           </a:xfrm>
           <a:prstGeom prst="rect">
             <a:avLst/>
@@ -4887,33 +5135,33 @@
               <a:buNone/>
             </a:pPr>
             <a:r>
-              <a:rPr lang="en-US" sz="1200" dirty="0">
-                <a:solidFill>
-                  <a:srgbClr val="FFFFFF"/>
-                </a:solidFill>
-              </a:rPr>
-              <a:t>$200K</a:t>
-            </a:r>
-            <a:endParaRPr lang="en-US" sz="1200" dirty="0"/>
-          </a:p>
-        </p:txBody>
-      </p:sp>
-      <p:sp>
-        <p:nvSpPr>
-          <p:cNvPr id="34" name="Shape 32"/>
+              <a:rPr lang="en-US" sz="1100" dirty="0">
+                <a:solidFill>
+                  <a:srgbClr val="2ECC71"/>
+                </a:solidFill>
+              </a:rPr>
+              <a:t>✓</a:t>
+            </a:r>
+            <a:endParaRPr lang="en-US" sz="1100" dirty="0"/>
+          </a:p>
+        </p:txBody>
+      </p:sp>
+      <p:sp>
+        <p:nvSpPr>
+          <p:cNvPr id="38" name="Shape 36"/>
           <p:cNvSpPr/>
           <p:nvPr/>
         </p:nvSpPr>
         <p:spPr>
           <a:xfrm>
-            <a:off x="6720840" y="2148840"/>
-            <a:ext cx="2103120" cy="393192"/>
-          </a:xfrm>
-          <a:prstGeom prst="rect">
-            <a:avLst/>
-          </a:prstGeom>
-          <a:solidFill>
-            <a:srgbClr val="1C1C1C"/>
+            <a:off x="7543800" y="1554480"/>
+            <a:ext cx="1005840" cy="365760"/>
+          </a:xfrm>
+          <a:prstGeom prst="rect">
+            <a:avLst/>
+          </a:prstGeom>
+          <a:solidFill>
+            <a:srgbClr val="1A2035"/>
           </a:solidFill>
           <a:ln w="12700">
             <a:solidFill>
@@ -4925,14 +5173,14 @@
       </p:sp>
       <p:sp>
         <p:nvSpPr>
-          <p:cNvPr id="35" name="Text 33"/>
-          <p:cNvSpPr txBox="1"/>
-          <p:nvPr/>
-        </p:nvSpPr>
-        <p:spPr>
-          <a:xfrm>
-            <a:off x="6784848" y="2176272"/>
-            <a:ext cx="2011680" cy="338328"/>
+          <p:cNvPr id="39" name="Text 37"/>
+          <p:cNvSpPr txBox="1"/>
+          <p:nvPr/>
+        </p:nvSpPr>
+        <p:spPr>
+          <a:xfrm>
+            <a:off x="7598664" y="1572768"/>
+            <a:ext cx="914400" cy="329184"/>
           </a:xfrm>
           <a:prstGeom prst="rect">
             <a:avLst/>
@@ -4948,33 +5196,33 @@
               <a:buNone/>
             </a:pPr>
             <a:r>
-              <a:rPr lang="en-US" sz="1200" dirty="0">
+              <a:rPr lang="en-US" sz="1100" dirty="0">
                 <a:solidFill>
                   <a:srgbClr val="FFFFFF"/>
                 </a:solidFill>
               </a:rPr>
-              <a:t>$200K</a:t>
-            </a:r>
-            <a:endParaRPr lang="en-US" sz="1200" dirty="0"/>
-          </a:p>
-        </p:txBody>
-      </p:sp>
-      <p:sp>
-        <p:nvSpPr>
-          <p:cNvPr id="36" name="Shape 34"/>
+              <a:t>FY28 Q1</a:t>
+            </a:r>
+            <a:endParaRPr lang="en-US" sz="1100" dirty="0"/>
+          </a:p>
+        </p:txBody>
+      </p:sp>
+      <p:sp>
+        <p:nvSpPr>
+          <p:cNvPr id="40" name="Shape 38"/>
           <p:cNvSpPr/>
           <p:nvPr/>
         </p:nvSpPr>
         <p:spPr>
           <a:xfrm>
-            <a:off x="320040" y="2569464"/>
-            <a:ext cx="3246120" cy="393192"/>
-          </a:xfrm>
-          <a:prstGeom prst="rect">
-            <a:avLst/>
-          </a:prstGeom>
-          <a:solidFill>
-            <a:srgbClr val="222222"/>
+            <a:off x="274320" y="1920240"/>
+            <a:ext cx="2011680" cy="365760"/>
+          </a:xfrm>
+          <a:prstGeom prst="rect">
+            <a:avLst/>
+          </a:prstGeom>
+          <a:solidFill>
+            <a:srgbClr val="1C1C1C"/>
           </a:solidFill>
           <a:ln w="12700">
             <a:solidFill>
@@ -4986,14 +5234,14 @@
       </p:sp>
       <p:sp>
         <p:nvSpPr>
-          <p:cNvPr id="37" name="Text 35"/>
-          <p:cNvSpPr txBox="1"/>
-          <p:nvPr/>
-        </p:nvSpPr>
-        <p:spPr>
-          <a:xfrm>
-            <a:off x="384048" y="2596896"/>
-            <a:ext cx="3154680" cy="338328"/>
+          <p:cNvPr id="41" name="Text 39"/>
+          <p:cNvSpPr txBox="1"/>
+          <p:nvPr/>
+        </p:nvSpPr>
+        <p:spPr>
+          <a:xfrm>
+            <a:off x="329184" y="1938528"/>
+            <a:ext cx="1920240" cy="329184"/>
           </a:xfrm>
           <a:prstGeom prst="rect">
             <a:avLst/>
@@ -5009,33 +5257,33 @@
               <a:buNone/>
             </a:pPr>
             <a:r>
-              <a:rPr lang="en-US" sz="1100" dirty="0">
+              <a:rPr lang="en-US" sz="900" dirty="0">
                 <a:solidFill>
                   <a:srgbClr val="CCCCCC"/>
                 </a:solidFill>
               </a:rPr>
-              <a:t>M3: SSLC annual revenue ≥ $10M</a:t>
-            </a:r>
-            <a:endParaRPr lang="en-US" sz="1100" dirty="0"/>
-          </a:p>
-        </p:txBody>
-      </p:sp>
-      <p:sp>
-        <p:nvSpPr>
-          <p:cNvPr id="38" name="Shape 36"/>
+              <a:t>M2  Nebula/OTV production contract  →$200K</a:t>
+            </a:r>
+            <a:endParaRPr lang="en-US" sz="900" dirty="0"/>
+          </a:p>
+        </p:txBody>
+      </p:sp>
+      <p:sp>
+        <p:nvSpPr>
+          <p:cNvPr id="42" name="Shape 40"/>
           <p:cNvSpPr/>
           <p:nvPr/>
         </p:nvSpPr>
         <p:spPr>
           <a:xfrm>
-            <a:off x="3657600" y="2569464"/>
-            <a:ext cx="1463040" cy="393192"/>
-          </a:xfrm>
-          <a:prstGeom prst="rect">
-            <a:avLst/>
-          </a:prstGeom>
-          <a:solidFill>
-            <a:srgbClr val="222222"/>
+            <a:off x="2331720" y="1920240"/>
+            <a:ext cx="1874520" cy="365760"/>
+          </a:xfrm>
+          <a:prstGeom prst="rect">
+            <a:avLst/>
+          </a:prstGeom>
+          <a:solidFill>
+            <a:srgbClr val="1C1C1C"/>
           </a:solidFill>
           <a:ln w="12700">
             <a:solidFill>
@@ -5047,56 +5295,56 @@
       </p:sp>
       <p:sp>
         <p:nvSpPr>
-          <p:cNvPr id="39" name="Text 37"/>
-          <p:cNvSpPr txBox="1"/>
-          <p:nvPr/>
-        </p:nvSpPr>
-        <p:spPr>
-          <a:xfrm>
-            <a:off x="3721608" y="2596896"/>
-            <a:ext cx="1371600" cy="338328"/>
-          </a:xfrm>
-          <a:prstGeom prst="rect">
-            <a:avLst/>
-          </a:prstGeom>
-          <a:noFill/>
-          <a:ln/>
-        </p:spPr>
-        <p:txBody>
-          <a:bodyPr wrap="square" rtlCol="0" anchor="ctr"/>
-          <a:lstStyle/>
-          <a:p>
-            <a:pPr algn="ctr" indent="0" marL="0">
-              <a:buNone/>
-            </a:pPr>
-            <a:r>
-              <a:rPr lang="en-US" sz="1200" dirty="0">
-                <a:solidFill>
-                  <a:srgbClr val="888888"/>
-                </a:solidFill>
-              </a:rPr>
-              <a:t>—</a:t>
-            </a:r>
-            <a:endParaRPr lang="en-US" sz="1200" dirty="0"/>
-          </a:p>
-        </p:txBody>
-      </p:sp>
-      <p:sp>
-        <p:nvSpPr>
-          <p:cNvPr id="40" name="Shape 38"/>
+          <p:cNvPr id="43" name="Text 41"/>
+          <p:cNvSpPr txBox="1"/>
+          <p:nvPr/>
+        </p:nvSpPr>
+        <p:spPr>
+          <a:xfrm>
+            <a:off x="2386584" y="1938528"/>
+            <a:ext cx="1783080" cy="329184"/>
+          </a:xfrm>
+          <a:prstGeom prst="rect">
+            <a:avLst/>
+          </a:prstGeom>
+          <a:noFill/>
+          <a:ln/>
+        </p:spPr>
+        <p:txBody>
+          <a:bodyPr wrap="square" rtlCol="0" anchor="ctr"/>
+          <a:lstStyle/>
+          <a:p>
+            <a:pPr algn="l" indent="0" marL="0">
+              <a:buNone/>
+            </a:pPr>
+            <a:r>
+              <a:rPr lang="en-US" sz="900" dirty="0">
+                <a:solidFill>
+                  <a:srgbClr val="CCCCCC"/>
+                </a:solidFill>
+              </a:rPr>
+              <a:t>OTV production contract signed</a:t>
+            </a:r>
+            <a:endParaRPr lang="en-US" sz="900" dirty="0"/>
+          </a:p>
+        </p:txBody>
+      </p:sp>
+      <p:sp>
+        <p:nvSpPr>
+          <p:cNvPr id="44" name="Shape 42"/>
           <p:cNvSpPr/>
           <p:nvPr/>
         </p:nvSpPr>
         <p:spPr>
           <a:xfrm>
-            <a:off x="5257800" y="2569464"/>
-            <a:ext cx="1417320" cy="393192"/>
-          </a:xfrm>
-          <a:prstGeom prst="rect">
-            <a:avLst/>
-          </a:prstGeom>
-          <a:solidFill>
-            <a:srgbClr val="222222"/>
+            <a:off x="4251960" y="1920240"/>
+            <a:ext cx="1051560" cy="365760"/>
+          </a:xfrm>
+          <a:prstGeom prst="rect">
+            <a:avLst/>
+          </a:prstGeom>
+          <a:solidFill>
+            <a:srgbClr val="1C1C1C"/>
           </a:solidFill>
           <a:ln w="12700">
             <a:solidFill>
@@ -5108,14 +5356,14 @@
       </p:sp>
       <p:sp>
         <p:nvSpPr>
-          <p:cNvPr id="41" name="Text 39"/>
-          <p:cNvSpPr txBox="1"/>
-          <p:nvPr/>
-        </p:nvSpPr>
-        <p:spPr>
-          <a:xfrm>
-            <a:off x="5321808" y="2596896"/>
-            <a:ext cx="1325880" cy="338328"/>
+          <p:cNvPr id="45" name="Text 43"/>
+          <p:cNvSpPr txBox="1"/>
+          <p:nvPr/>
+        </p:nvSpPr>
+        <p:spPr>
+          <a:xfrm>
+            <a:off x="4306824" y="1938528"/>
+            <a:ext cx="960120" cy="329184"/>
           </a:xfrm>
           <a:prstGeom prst="rect">
             <a:avLst/>
@@ -5131,33 +5379,33 @@
               <a:buNone/>
             </a:pPr>
             <a:r>
-              <a:rPr lang="en-US" sz="1200" dirty="0">
-                <a:solidFill>
-                  <a:srgbClr val="FFFFFF"/>
-                </a:solidFill>
-              </a:rPr>
-              <a:t>$250K</a:t>
-            </a:r>
-            <a:endParaRPr lang="en-US" sz="1200" dirty="0"/>
-          </a:p>
-        </p:txBody>
-      </p:sp>
-      <p:sp>
-        <p:nvSpPr>
-          <p:cNvPr id="42" name="Shape 40"/>
+              <a:rPr lang="en-US" sz="1100" dirty="0">
+                <a:solidFill>
+                  <a:srgbClr val="555555"/>
+                </a:solidFill>
+              </a:rPr>
+              <a:t>—</a:t>
+            </a:r>
+            <a:endParaRPr lang="en-US" sz="1100" dirty="0"/>
+          </a:p>
+        </p:txBody>
+      </p:sp>
+      <p:sp>
+        <p:nvSpPr>
+          <p:cNvPr id="46" name="Shape 44"/>
           <p:cNvSpPr/>
           <p:nvPr/>
         </p:nvSpPr>
         <p:spPr>
           <a:xfrm>
-            <a:off x="6720840" y="2569464"/>
-            <a:ext cx="2103120" cy="393192"/>
-          </a:xfrm>
-          <a:prstGeom prst="rect">
-            <a:avLst/>
-          </a:prstGeom>
-          <a:solidFill>
-            <a:srgbClr val="222222"/>
+            <a:off x="5349240" y="1920240"/>
+            <a:ext cx="1051560" cy="365760"/>
+          </a:xfrm>
+          <a:prstGeom prst="rect">
+            <a:avLst/>
+          </a:prstGeom>
+          <a:solidFill>
+            <a:srgbClr val="1C1C1C"/>
           </a:solidFill>
           <a:ln w="12700">
             <a:solidFill>
@@ -5169,14 +5417,14 @@
       </p:sp>
       <p:sp>
         <p:nvSpPr>
-          <p:cNvPr id="43" name="Text 41"/>
-          <p:cNvSpPr txBox="1"/>
-          <p:nvPr/>
-        </p:nvSpPr>
-        <p:spPr>
-          <a:xfrm>
-            <a:off x="6784848" y="2596896"/>
-            <a:ext cx="2011680" cy="338328"/>
+          <p:cNvPr id="47" name="Text 45"/>
+          <p:cNvSpPr txBox="1"/>
+          <p:nvPr/>
+        </p:nvSpPr>
+        <p:spPr>
+          <a:xfrm>
+            <a:off x="5404104" y="1938528"/>
+            <a:ext cx="960120" cy="329184"/>
           </a:xfrm>
           <a:prstGeom prst="rect">
             <a:avLst/>
@@ -5192,27 +5440,27 @@
               <a:buNone/>
             </a:pPr>
             <a:r>
-              <a:rPr lang="en-US" sz="1200" dirty="0">
-                <a:solidFill>
-                  <a:srgbClr val="FFFFFF"/>
-                </a:solidFill>
-              </a:rPr>
-              <a:t>$250K</a:t>
-            </a:r>
-            <a:endParaRPr lang="en-US" sz="1200" dirty="0"/>
-          </a:p>
-        </p:txBody>
-      </p:sp>
-      <p:sp>
-        <p:nvSpPr>
-          <p:cNvPr id="44" name="Shape 42"/>
+              <a:rPr lang="en-US" sz="1100" dirty="0">
+                <a:solidFill>
+                  <a:srgbClr val="2ECC71"/>
+                </a:solidFill>
+              </a:rPr>
+              <a:t>✓</a:t>
+            </a:r>
+            <a:endParaRPr lang="en-US" sz="1100" dirty="0"/>
+          </a:p>
+        </p:txBody>
+      </p:sp>
+      <p:sp>
+        <p:nvSpPr>
+          <p:cNvPr id="48" name="Shape 46"/>
           <p:cNvSpPr/>
           <p:nvPr/>
         </p:nvSpPr>
         <p:spPr>
           <a:xfrm>
-            <a:off x="320040" y="2990088"/>
-            <a:ext cx="3246120" cy="393192"/>
+            <a:off x="6446520" y="1920240"/>
+            <a:ext cx="1051560" cy="365760"/>
           </a:xfrm>
           <a:prstGeom prst="rect">
             <a:avLst/>
@@ -5230,35 +5478,35 @@
       </p:sp>
       <p:sp>
         <p:nvSpPr>
-          <p:cNvPr id="45" name="Text 43"/>
-          <p:cNvSpPr txBox="1"/>
-          <p:nvPr/>
-        </p:nvSpPr>
-        <p:spPr>
-          <a:xfrm>
-            <a:off x="384048" y="3017520"/>
-            <a:ext cx="3154680" cy="338328"/>
-          </a:xfrm>
-          <a:prstGeom prst="rect">
-            <a:avLst/>
-          </a:prstGeom>
-          <a:noFill/>
-          <a:ln/>
-        </p:spPr>
-        <p:txBody>
-          <a:bodyPr wrap="square" rtlCol="0" anchor="ctr"/>
-          <a:lstStyle/>
-          <a:p>
-            <a:pPr algn="l" indent="0" marL="0">
+          <p:cNvPr id="49" name="Text 47"/>
+          <p:cNvSpPr txBox="1"/>
+          <p:nvPr/>
+        </p:nvSpPr>
+        <p:spPr>
+          <a:xfrm>
+            <a:off x="6501384" y="1938528"/>
+            <a:ext cx="960120" cy="329184"/>
+          </a:xfrm>
+          <a:prstGeom prst="rect">
+            <a:avLst/>
+          </a:prstGeom>
+          <a:noFill/>
+          <a:ln/>
+        </p:spPr>
+        <p:txBody>
+          <a:bodyPr wrap="square" rtlCol="0" anchor="ctr"/>
+          <a:lstStyle/>
+          <a:p>
+            <a:pPr algn="ctr" indent="0" marL="0">
               <a:buNone/>
             </a:pPr>
             <a:r>
               <a:rPr lang="en-US" sz="1100" dirty="0">
                 <a:solidFill>
-                  <a:srgbClr val="CCCCCC"/>
-                </a:solidFill>
-              </a:rPr>
-              <a:t>M4: SSLC annual revenue ≥ $20M</a:t>
+                  <a:srgbClr val="2ECC71"/>
+                </a:solidFill>
+              </a:rPr>
+              <a:t>✓</a:t>
             </a:r>
             <a:endParaRPr lang="en-US" sz="1100" dirty="0"/>
           </a:p>
@@ -5266,14 +5514,14 @@
       </p:sp>
       <p:sp>
         <p:nvSpPr>
-          <p:cNvPr id="46" name="Shape 44"/>
+          <p:cNvPr id="50" name="Shape 48"/>
           <p:cNvSpPr/>
           <p:nvPr/>
         </p:nvSpPr>
         <p:spPr>
           <a:xfrm>
-            <a:off x="3657600" y="2990088"/>
-            <a:ext cx="1463040" cy="393192"/>
+            <a:off x="7543800" y="1920240"/>
+            <a:ext cx="1005840" cy="365760"/>
           </a:xfrm>
           <a:prstGeom prst="rect">
             <a:avLst/>
@@ -5291,14 +5539,14 @@
       </p:sp>
       <p:sp>
         <p:nvSpPr>
-          <p:cNvPr id="47" name="Text 45"/>
-          <p:cNvSpPr txBox="1"/>
-          <p:nvPr/>
-        </p:nvSpPr>
-        <p:spPr>
-          <a:xfrm>
-            <a:off x="3721608" y="3017520"/>
-            <a:ext cx="1371600" cy="338328"/>
+          <p:cNvPr id="51" name="Text 49"/>
+          <p:cNvSpPr txBox="1"/>
+          <p:nvPr/>
+        </p:nvSpPr>
+        <p:spPr>
+          <a:xfrm>
+            <a:off x="7598664" y="1938528"/>
+            <a:ext cx="914400" cy="329184"/>
           </a:xfrm>
           <a:prstGeom prst="rect">
             <a:avLst/>
@@ -5314,33 +5562,33 @@
               <a:buNone/>
             </a:pPr>
             <a:r>
-              <a:rPr lang="en-US" sz="1200" dirty="0">
-                <a:solidFill>
-                  <a:srgbClr val="888888"/>
-                </a:solidFill>
-              </a:rPr>
-              <a:t>—</a:t>
-            </a:r>
-            <a:endParaRPr lang="en-US" sz="1200" dirty="0"/>
-          </a:p>
-        </p:txBody>
-      </p:sp>
-      <p:sp>
-        <p:nvSpPr>
-          <p:cNvPr id="48" name="Shape 46"/>
+              <a:rPr lang="en-US" sz="1100" dirty="0">
+                <a:solidFill>
+                  <a:srgbClr val="FFFFFF"/>
+                </a:solidFill>
+              </a:rPr>
+              <a:t>At signing</a:t>
+            </a:r>
+            <a:endParaRPr lang="en-US" sz="1100" dirty="0"/>
+          </a:p>
+        </p:txBody>
+      </p:sp>
+      <p:sp>
+        <p:nvSpPr>
+          <p:cNvPr id="52" name="Shape 50"/>
           <p:cNvSpPr/>
           <p:nvPr/>
         </p:nvSpPr>
         <p:spPr>
           <a:xfrm>
-            <a:off x="5257800" y="2990088"/>
-            <a:ext cx="1417320" cy="393192"/>
-          </a:xfrm>
-          <a:prstGeom prst="rect">
-            <a:avLst/>
-          </a:prstGeom>
-          <a:solidFill>
-            <a:srgbClr val="1C1C1C"/>
+            <a:off x="274320" y="2286000"/>
+            <a:ext cx="2011680" cy="365760"/>
+          </a:xfrm>
+          <a:prstGeom prst="rect">
+            <a:avLst/>
+          </a:prstGeom>
+          <a:solidFill>
+            <a:srgbClr val="1A2035"/>
           </a:solidFill>
           <a:ln w="12700">
             <a:solidFill>
@@ -5352,56 +5600,56 @@
       </p:sp>
       <p:sp>
         <p:nvSpPr>
-          <p:cNvPr id="49" name="Text 47"/>
-          <p:cNvSpPr txBox="1"/>
-          <p:nvPr/>
-        </p:nvSpPr>
-        <p:spPr>
-          <a:xfrm>
-            <a:off x="5321808" y="3017520"/>
-            <a:ext cx="1325880" cy="338328"/>
-          </a:xfrm>
-          <a:prstGeom prst="rect">
-            <a:avLst/>
-          </a:prstGeom>
-          <a:noFill/>
-          <a:ln/>
-        </p:spPr>
-        <p:txBody>
-          <a:bodyPr wrap="square" rtlCol="0" anchor="ctr"/>
-          <a:lstStyle/>
-          <a:p>
-            <a:pPr algn="ctr" indent="0" marL="0">
-              <a:buNone/>
-            </a:pPr>
-            <a:r>
-              <a:rPr lang="en-US" sz="1200" dirty="0">
-                <a:solidFill>
-                  <a:srgbClr val="888888"/>
-                </a:solidFill>
-              </a:rPr>
-              <a:t>—</a:t>
-            </a:r>
-            <a:endParaRPr lang="en-US" sz="1200" dirty="0"/>
-          </a:p>
-        </p:txBody>
-      </p:sp>
-      <p:sp>
-        <p:nvSpPr>
-          <p:cNvPr id="50" name="Shape 48"/>
+          <p:cNvPr id="53" name="Text 51"/>
+          <p:cNvSpPr txBox="1"/>
+          <p:nvPr/>
+        </p:nvSpPr>
+        <p:spPr>
+          <a:xfrm>
+            <a:off x="329184" y="2304288"/>
+            <a:ext cx="1920240" cy="329184"/>
+          </a:xfrm>
+          <a:prstGeom prst="rect">
+            <a:avLst/>
+          </a:prstGeom>
+          <a:noFill/>
+          <a:ln/>
+        </p:spPr>
+        <p:txBody>
+          <a:bodyPr wrap="square" rtlCol="0" anchor="ctr"/>
+          <a:lstStyle/>
+          <a:p>
+            <a:pPr algn="l" indent="0" marL="0">
+              <a:buNone/>
+            </a:pPr>
+            <a:r>
+              <a:rPr lang="en-US" sz="900" dirty="0">
+                <a:solidFill>
+                  <a:srgbClr val="CCCCCC"/>
+                </a:solidFill>
+              </a:rPr>
+              <a:t>M3  SSLC annual rev ≥$10M  →$250K</a:t>
+            </a:r>
+            <a:endParaRPr lang="en-US" sz="900" dirty="0"/>
+          </a:p>
+        </p:txBody>
+      </p:sp>
+      <p:sp>
+        <p:nvSpPr>
+          <p:cNvPr id="54" name="Shape 52"/>
           <p:cNvSpPr/>
           <p:nvPr/>
         </p:nvSpPr>
         <p:spPr>
           <a:xfrm>
-            <a:off x="6720840" y="2990088"/>
-            <a:ext cx="2103120" cy="393192"/>
-          </a:xfrm>
-          <a:prstGeom prst="rect">
-            <a:avLst/>
-          </a:prstGeom>
-          <a:solidFill>
-            <a:srgbClr val="1C1C1C"/>
+            <a:off x="2331720" y="2286000"/>
+            <a:ext cx="1874520" cy="365760"/>
+          </a:xfrm>
+          <a:prstGeom prst="rect">
+            <a:avLst/>
+          </a:prstGeom>
+          <a:solidFill>
+            <a:srgbClr val="1A2035"/>
           </a:solidFill>
           <a:ln w="12700">
             <a:solidFill>
@@ -5413,56 +5661,56 @@
       </p:sp>
       <p:sp>
         <p:nvSpPr>
-          <p:cNvPr id="51" name="Text 49"/>
-          <p:cNvSpPr txBox="1"/>
-          <p:nvPr/>
-        </p:nvSpPr>
-        <p:spPr>
-          <a:xfrm>
-            <a:off x="6784848" y="3017520"/>
-            <a:ext cx="2011680" cy="338328"/>
-          </a:xfrm>
-          <a:prstGeom prst="rect">
-            <a:avLst/>
-          </a:prstGeom>
-          <a:noFill/>
-          <a:ln/>
-        </p:spPr>
-        <p:txBody>
-          <a:bodyPr wrap="square" rtlCol="0" anchor="ctr"/>
-          <a:lstStyle/>
-          <a:p>
-            <a:pPr algn="ctr" indent="0" marL="0">
-              <a:buNone/>
-            </a:pPr>
-            <a:r>
-              <a:rPr lang="en-US" sz="1200" dirty="0">
-                <a:solidFill>
-                  <a:srgbClr val="FFFFFF"/>
-                </a:solidFill>
-              </a:rPr>
-              <a:t>$250K</a:t>
-            </a:r>
-            <a:endParaRPr lang="en-US" sz="1200" dirty="0"/>
-          </a:p>
-        </p:txBody>
-      </p:sp>
-      <p:sp>
-        <p:nvSpPr>
-          <p:cNvPr id="52" name="Shape 50"/>
+          <p:cNvPr id="55" name="Text 53"/>
+          <p:cNvSpPr txBox="1"/>
+          <p:nvPr/>
+        </p:nvSpPr>
+        <p:spPr>
+          <a:xfrm>
+            <a:off x="2386584" y="2304288"/>
+            <a:ext cx="1783080" cy="329184"/>
+          </a:xfrm>
+          <a:prstGeom prst="rect">
+            <a:avLst/>
+          </a:prstGeom>
+          <a:noFill/>
+          <a:ln/>
+        </p:spPr>
+        <p:txBody>
+          <a:bodyPr wrap="square" rtlCol="0" anchor="ctr"/>
+          <a:lstStyle/>
+          <a:p>
+            <a:pPr algn="l" indent="0" marL="0">
+              <a:buNone/>
+            </a:pPr>
+            <a:r>
+              <a:rPr lang="en-US" sz="900" dirty="0">
+                <a:solidFill>
+                  <a:srgbClr val="CCCCCC"/>
+                </a:solidFill>
+              </a:rPr>
+              <a:t>Annual rev ≥$10M</a:t>
+            </a:r>
+            <a:endParaRPr lang="en-US" sz="900" dirty="0"/>
+          </a:p>
+        </p:txBody>
+      </p:sp>
+      <p:sp>
+        <p:nvSpPr>
+          <p:cNvPr id="56" name="Shape 54"/>
           <p:cNvSpPr/>
           <p:nvPr/>
         </p:nvSpPr>
         <p:spPr>
           <a:xfrm>
-            <a:off x="320040" y="3410712"/>
-            <a:ext cx="3246120" cy="393192"/>
-          </a:xfrm>
-          <a:prstGeom prst="rect">
-            <a:avLst/>
-          </a:prstGeom>
-          <a:solidFill>
-            <a:srgbClr val="222222"/>
+            <a:off x="4251960" y="2286000"/>
+            <a:ext cx="1051560" cy="365760"/>
+          </a:xfrm>
+          <a:prstGeom prst="rect">
+            <a:avLst/>
+          </a:prstGeom>
+          <a:solidFill>
+            <a:srgbClr val="1A2035"/>
           </a:solidFill>
           <a:ln w="12700">
             <a:solidFill>
@@ -5474,35 +5722,35 @@
       </p:sp>
       <p:sp>
         <p:nvSpPr>
-          <p:cNvPr id="53" name="Text 51"/>
-          <p:cNvSpPr txBox="1"/>
-          <p:nvPr/>
-        </p:nvSpPr>
-        <p:spPr>
-          <a:xfrm>
-            <a:off x="384048" y="3438144"/>
-            <a:ext cx="3154680" cy="338328"/>
-          </a:xfrm>
-          <a:prstGeom prst="rect">
-            <a:avLst/>
-          </a:prstGeom>
-          <a:noFill/>
-          <a:ln/>
-        </p:spPr>
-        <p:txBody>
-          <a:bodyPr wrap="square" rtlCol="0" anchor="ctr"/>
-          <a:lstStyle/>
-          <a:p>
-            <a:pPr algn="l" indent="0" marL="0">
+          <p:cNvPr id="57" name="Text 55"/>
+          <p:cNvSpPr txBox="1"/>
+          <p:nvPr/>
+        </p:nvSpPr>
+        <p:spPr>
+          <a:xfrm>
+            <a:off x="4306824" y="2304288"/>
+            <a:ext cx="960120" cy="329184"/>
+          </a:xfrm>
+          <a:prstGeom prst="rect">
+            <a:avLst/>
+          </a:prstGeom>
+          <a:noFill/>
+          <a:ln/>
+        </p:spPr>
+        <p:txBody>
+          <a:bodyPr wrap="square" rtlCol="0" anchor="ctr"/>
+          <a:lstStyle/>
+          <a:p>
+            <a:pPr algn="ctr" indent="0" marL="0">
               <a:buNone/>
             </a:pPr>
             <a:r>
               <a:rPr lang="en-US" sz="1100" dirty="0">
                 <a:solidFill>
-                  <a:srgbClr val="CCCCCC"/>
-                </a:solidFill>
-              </a:rPr>
-              <a:t>M5: BLK3 tank qualification complete</a:t>
+                  <a:srgbClr val="555555"/>
+                </a:solidFill>
+              </a:rPr>
+              <a:t>—</a:t>
             </a:r>
             <a:endParaRPr lang="en-US" sz="1100" dirty="0"/>
           </a:p>
@@ -5510,20 +5758,20 @@
       </p:sp>
       <p:sp>
         <p:nvSpPr>
-          <p:cNvPr id="54" name="Shape 52"/>
+          <p:cNvPr id="58" name="Shape 56"/>
           <p:cNvSpPr/>
           <p:nvPr/>
         </p:nvSpPr>
         <p:spPr>
           <a:xfrm>
-            <a:off x="3657600" y="3410712"/>
-            <a:ext cx="1463040" cy="393192"/>
-          </a:xfrm>
-          <a:prstGeom prst="rect">
-            <a:avLst/>
-          </a:prstGeom>
-          <a:solidFill>
-            <a:srgbClr val="222222"/>
+            <a:off x="5349240" y="2286000"/>
+            <a:ext cx="1051560" cy="365760"/>
+          </a:xfrm>
+          <a:prstGeom prst="rect">
+            <a:avLst/>
+          </a:prstGeom>
+          <a:solidFill>
+            <a:srgbClr val="1A2035"/>
           </a:solidFill>
           <a:ln w="12700">
             <a:solidFill>
@@ -5535,14 +5783,14 @@
       </p:sp>
       <p:sp>
         <p:nvSpPr>
-          <p:cNvPr id="55" name="Text 53"/>
-          <p:cNvSpPr txBox="1"/>
-          <p:nvPr/>
-        </p:nvSpPr>
-        <p:spPr>
-          <a:xfrm>
-            <a:off x="3721608" y="3438144"/>
-            <a:ext cx="1371600" cy="338328"/>
+          <p:cNvPr id="59" name="Text 57"/>
+          <p:cNvSpPr txBox="1"/>
+          <p:nvPr/>
+        </p:nvSpPr>
+        <p:spPr>
+          <a:xfrm>
+            <a:off x="5404104" y="2304288"/>
+            <a:ext cx="960120" cy="329184"/>
           </a:xfrm>
           <a:prstGeom prst="rect">
             <a:avLst/>
@@ -5558,33 +5806,33 @@
               <a:buNone/>
             </a:pPr>
             <a:r>
-              <a:rPr lang="en-US" sz="1200" dirty="0">
-                <a:solidFill>
-                  <a:srgbClr val="888888"/>
-                </a:solidFill>
-              </a:rPr>
-              <a:t>—</a:t>
-            </a:r>
-            <a:endParaRPr lang="en-US" sz="1200" dirty="0"/>
-          </a:p>
-        </p:txBody>
-      </p:sp>
-      <p:sp>
-        <p:nvSpPr>
-          <p:cNvPr id="56" name="Shape 54"/>
+              <a:rPr lang="en-US" sz="1100" dirty="0">
+                <a:solidFill>
+                  <a:srgbClr val="2ECC71"/>
+                </a:solidFill>
+              </a:rPr>
+              <a:t>✓</a:t>
+            </a:r>
+            <a:endParaRPr lang="en-US" sz="1100" dirty="0"/>
+          </a:p>
+        </p:txBody>
+      </p:sp>
+      <p:sp>
+        <p:nvSpPr>
+          <p:cNvPr id="60" name="Shape 58"/>
           <p:cNvSpPr/>
           <p:nvPr/>
         </p:nvSpPr>
         <p:spPr>
           <a:xfrm>
-            <a:off x="5257800" y="3410712"/>
-            <a:ext cx="1417320" cy="393192"/>
-          </a:xfrm>
-          <a:prstGeom prst="rect">
-            <a:avLst/>
-          </a:prstGeom>
-          <a:solidFill>
-            <a:srgbClr val="222222"/>
+            <a:off x="6446520" y="2286000"/>
+            <a:ext cx="1051560" cy="365760"/>
+          </a:xfrm>
+          <a:prstGeom prst="rect">
+            <a:avLst/>
+          </a:prstGeom>
+          <a:solidFill>
+            <a:srgbClr val="1A2035"/>
           </a:solidFill>
           <a:ln w="12700">
             <a:solidFill>
@@ -5596,14 +5844,14 @@
       </p:sp>
       <p:sp>
         <p:nvSpPr>
-          <p:cNvPr id="57" name="Text 55"/>
-          <p:cNvSpPr txBox="1"/>
-          <p:nvPr/>
-        </p:nvSpPr>
-        <p:spPr>
-          <a:xfrm>
-            <a:off x="5321808" y="3438144"/>
-            <a:ext cx="1325880" cy="338328"/>
+          <p:cNvPr id="61" name="Text 59"/>
+          <p:cNvSpPr txBox="1"/>
+          <p:nvPr/>
+        </p:nvSpPr>
+        <p:spPr>
+          <a:xfrm>
+            <a:off x="6501384" y="2304288"/>
+            <a:ext cx="960120" cy="329184"/>
           </a:xfrm>
           <a:prstGeom prst="rect">
             <a:avLst/>
@@ -5619,33 +5867,33 @@
               <a:buNone/>
             </a:pPr>
             <a:r>
-              <a:rPr lang="en-US" sz="1200" dirty="0">
-                <a:solidFill>
-                  <a:srgbClr val="888888"/>
-                </a:solidFill>
-              </a:rPr>
-              <a:t>—</a:t>
-            </a:r>
-            <a:endParaRPr lang="en-US" sz="1200" dirty="0"/>
-          </a:p>
-        </p:txBody>
-      </p:sp>
-      <p:sp>
-        <p:nvSpPr>
-          <p:cNvPr id="58" name="Shape 56"/>
+              <a:rPr lang="en-US" sz="1100" dirty="0">
+                <a:solidFill>
+                  <a:srgbClr val="2ECC71"/>
+                </a:solidFill>
+              </a:rPr>
+              <a:t>✓</a:t>
+            </a:r>
+            <a:endParaRPr lang="en-US" sz="1100" dirty="0"/>
+          </a:p>
+        </p:txBody>
+      </p:sp>
+      <p:sp>
+        <p:nvSpPr>
+          <p:cNvPr id="62" name="Shape 60"/>
           <p:cNvSpPr/>
           <p:nvPr/>
         </p:nvSpPr>
         <p:spPr>
           <a:xfrm>
-            <a:off x="6720840" y="3410712"/>
-            <a:ext cx="2103120" cy="393192"/>
-          </a:xfrm>
-          <a:prstGeom prst="rect">
-            <a:avLst/>
-          </a:prstGeom>
-          <a:solidFill>
-            <a:srgbClr val="222222"/>
+            <a:off x="7543800" y="2286000"/>
+            <a:ext cx="1005840" cy="365760"/>
+          </a:xfrm>
+          <a:prstGeom prst="rect">
+            <a:avLst/>
+          </a:prstGeom>
+          <a:solidFill>
+            <a:srgbClr val="1A2035"/>
           </a:solidFill>
           <a:ln w="12700">
             <a:solidFill>
@@ -5657,14 +5905,14 @@
       </p:sp>
       <p:sp>
         <p:nvSpPr>
-          <p:cNvPr id="59" name="Text 57"/>
-          <p:cNvSpPr txBox="1"/>
-          <p:nvPr/>
-        </p:nvSpPr>
-        <p:spPr>
-          <a:xfrm>
-            <a:off x="6784848" y="3438144"/>
-            <a:ext cx="2011680" cy="338328"/>
+          <p:cNvPr id="63" name="Text 61"/>
+          <p:cNvSpPr txBox="1"/>
+          <p:nvPr/>
+        </p:nvSpPr>
+        <p:spPr>
+          <a:xfrm>
+            <a:off x="7598664" y="2304288"/>
+            <a:ext cx="914400" cy="329184"/>
           </a:xfrm>
           <a:prstGeom prst="rect">
             <a:avLst/>
@@ -5680,27 +5928,27 @@
               <a:buNone/>
             </a:pPr>
             <a:r>
-              <a:rPr lang="en-US" sz="1200" dirty="0">
+              <a:rPr lang="en-US" sz="1100" dirty="0">
                 <a:solidFill>
                   <a:srgbClr val="FFFFFF"/>
                 </a:solidFill>
               </a:rPr>
-              <a:t>$200K</a:t>
-            </a:r>
-            <a:endParaRPr lang="en-US" sz="1200" dirty="0"/>
-          </a:p>
-        </p:txBody>
-      </p:sp>
-      <p:sp>
-        <p:nvSpPr>
-          <p:cNvPr id="60" name="Shape 58"/>
+              <a:t>Est. FY29</a:t>
+            </a:r>
+            <a:endParaRPr lang="en-US" sz="1100" dirty="0"/>
+          </a:p>
+        </p:txBody>
+      </p:sp>
+      <p:sp>
+        <p:nvSpPr>
+          <p:cNvPr id="64" name="Shape 62"/>
           <p:cNvSpPr/>
           <p:nvPr/>
         </p:nvSpPr>
         <p:spPr>
           <a:xfrm>
-            <a:off x="320040" y="3831336"/>
-            <a:ext cx="3246120" cy="393192"/>
+            <a:off x="274320" y="2651760"/>
+            <a:ext cx="2011680" cy="365760"/>
           </a:xfrm>
           <a:prstGeom prst="rect">
             <a:avLst/>
@@ -5718,14 +5966,14 @@
       </p:sp>
       <p:sp>
         <p:nvSpPr>
-          <p:cNvPr id="61" name="Text 59"/>
-          <p:cNvSpPr txBox="1"/>
-          <p:nvPr/>
-        </p:nvSpPr>
-        <p:spPr>
-          <a:xfrm>
-            <a:off x="384048" y="3858768"/>
-            <a:ext cx="3154680" cy="338328"/>
+          <p:cNvPr id="65" name="Text 63"/>
+          <p:cNvSpPr txBox="1"/>
+          <p:nvPr/>
+        </p:nvSpPr>
+        <p:spPr>
+          <a:xfrm>
+            <a:off x="329184" y="2670048"/>
+            <a:ext cx="1920240" cy="329184"/>
           </a:xfrm>
           <a:prstGeom prst="rect">
             <a:avLst/>
@@ -5741,27 +5989,27 @@
               <a:buNone/>
             </a:pPr>
             <a:r>
-              <a:rPr lang="en-US" sz="1100" dirty="0">
+              <a:rPr lang="en-US" sz="900" dirty="0">
                 <a:solidFill>
                   <a:srgbClr val="CCCCCC"/>
                 </a:solidFill>
               </a:rPr>
-              <a:t>Stock earn-out at listing (additional equity)</a:t>
-            </a:r>
-            <a:endParaRPr lang="en-US" sz="1100" dirty="0"/>
-          </a:p>
-        </p:txBody>
-      </p:sp>
-      <p:sp>
-        <p:nvSpPr>
-          <p:cNvPr id="62" name="Shape 60"/>
+              <a:t>M4  SSLC annual rev ≥$20M  →$250K</a:t>
+            </a:r>
+            <a:endParaRPr lang="en-US" sz="900" dirty="0"/>
+          </a:p>
+        </p:txBody>
+      </p:sp>
+      <p:sp>
+        <p:nvSpPr>
+          <p:cNvPr id="66" name="Shape 64"/>
           <p:cNvSpPr/>
           <p:nvPr/>
         </p:nvSpPr>
         <p:spPr>
           <a:xfrm>
-            <a:off x="3657600" y="3831336"/>
-            <a:ext cx="1463040" cy="393192"/>
+            <a:off x="2331720" y="2651760"/>
+            <a:ext cx="1874520" cy="365760"/>
           </a:xfrm>
           <a:prstGeom prst="rect">
             <a:avLst/>
@@ -5779,64 +6027,50 @@
       </p:sp>
       <p:sp>
         <p:nvSpPr>
-          <p:cNvPr id="63" name="Text 61"/>
-          <p:cNvSpPr txBox="1"/>
-          <p:nvPr/>
-        </p:nvSpPr>
-        <p:spPr>
-          <a:xfrm>
-            <a:off x="3721608" y="3858768"/>
-            <a:ext cx="1371600" cy="338328"/>
-          </a:xfrm>
-          <a:prstGeom prst="rect">
-            <a:avLst/>
-          </a:prstGeom>
-          <a:noFill/>
-          <a:ln/>
-        </p:spPr>
-        <p:txBody>
-          <a:bodyPr wrap="square" rtlCol="0" anchor="ctr"/>
-          <a:lstStyle/>
-          <a:p>
-            <a:pPr algn="ctr" indent="0" marL="0">
-              <a:buNone/>
-            </a:pPr>
-            <a:r>
-              <a:rPr lang="en-US" sz="1200" dirty="0">
-                <a:solidFill>
-                  <a:srgbClr val="888888"/>
-                </a:solidFill>
-              </a:rPr>
-              <a:t>$0</a:t>
-            </a:r>
-            <a:endParaRPr lang="en-US" sz="1200" dirty="0"/>
-          </a:p>
-          <a:p>
-            <a:pPr algn="ctr" indent="0" marL="0">
-              <a:buNone/>
-            </a:pPr>
-            <a:r>
-              <a:rPr lang="en-US" sz="1200" dirty="0">
-                <a:solidFill>
-                  <a:srgbClr val="888888"/>
-                </a:solidFill>
-              </a:rPr>
-              <a:t>(0.0%)</a:t>
-            </a:r>
-            <a:endParaRPr lang="en-US" sz="1200" dirty="0"/>
-          </a:p>
-        </p:txBody>
-      </p:sp>
-      <p:sp>
-        <p:nvSpPr>
-          <p:cNvPr id="64" name="Shape 62"/>
+          <p:cNvPr id="67" name="Text 65"/>
+          <p:cNvSpPr txBox="1"/>
+          <p:nvPr/>
+        </p:nvSpPr>
+        <p:spPr>
+          <a:xfrm>
+            <a:off x="2386584" y="2670048"/>
+            <a:ext cx="1783080" cy="329184"/>
+          </a:xfrm>
+          <a:prstGeom prst="rect">
+            <a:avLst/>
+          </a:prstGeom>
+          <a:noFill/>
+          <a:ln/>
+        </p:spPr>
+        <p:txBody>
+          <a:bodyPr wrap="square" rtlCol="0" anchor="ctr"/>
+          <a:lstStyle/>
+          <a:p>
+            <a:pPr algn="l" indent="0" marL="0">
+              <a:buNone/>
+            </a:pPr>
+            <a:r>
+              <a:rPr lang="en-US" sz="900" dirty="0">
+                <a:solidFill>
+                  <a:srgbClr val="CCCCCC"/>
+                </a:solidFill>
+              </a:rPr>
+              <a:t>Annual rev ≥$20M</a:t>
+            </a:r>
+            <a:endParaRPr lang="en-US" sz="900" dirty="0"/>
+          </a:p>
+        </p:txBody>
+      </p:sp>
+      <p:sp>
+        <p:nvSpPr>
+          <p:cNvPr id="68" name="Shape 66"/>
           <p:cNvSpPr/>
           <p:nvPr/>
         </p:nvSpPr>
         <p:spPr>
           <a:xfrm>
-            <a:off x="5257800" y="3831336"/>
-            <a:ext cx="1417320" cy="393192"/>
+            <a:off x="4251960" y="2651760"/>
+            <a:ext cx="1051560" cy="365760"/>
           </a:xfrm>
           <a:prstGeom prst="rect">
             <a:avLst/>
@@ -5854,14 +6088,14 @@
       </p:sp>
       <p:sp>
         <p:nvSpPr>
-          <p:cNvPr id="65" name="Text 63"/>
-          <p:cNvSpPr txBox="1"/>
-          <p:nvPr/>
-        </p:nvSpPr>
-        <p:spPr>
-          <a:xfrm>
-            <a:off x="5321808" y="3858768"/>
-            <a:ext cx="1325880" cy="338328"/>
+          <p:cNvPr id="69" name="Text 67"/>
+          <p:cNvSpPr txBox="1"/>
+          <p:nvPr/>
+        </p:nvSpPr>
+        <p:spPr>
+          <a:xfrm>
+            <a:off x="4306824" y="2670048"/>
+            <a:ext cx="960120" cy="329184"/>
           </a:xfrm>
           <a:prstGeom prst="rect">
             <a:avLst/>
@@ -5877,41 +6111,27 @@
               <a:buNone/>
             </a:pPr>
             <a:r>
-              <a:rPr lang="en-US" sz="1200" dirty="0">
-                <a:solidFill>
-                  <a:srgbClr val="FFFFFF"/>
-                </a:solidFill>
-              </a:rPr>
-              <a:t>$625K</a:t>
-            </a:r>
-            <a:endParaRPr lang="en-US" sz="1200" dirty="0"/>
-          </a:p>
-          <a:p>
-            <a:pPr algn="ctr" indent="0" marL="0">
-              <a:buNone/>
-            </a:pPr>
-            <a:r>
-              <a:rPr lang="en-US" sz="1200" dirty="0">
-                <a:solidFill>
-                  <a:srgbClr val="FFFFFF"/>
-                </a:solidFill>
-              </a:rPr>
-              <a:t>(0.25%)</a:t>
-            </a:r>
-            <a:endParaRPr lang="en-US" sz="1200" dirty="0"/>
-          </a:p>
-        </p:txBody>
-      </p:sp>
-      <p:sp>
-        <p:nvSpPr>
-          <p:cNvPr id="66" name="Shape 64"/>
+              <a:rPr lang="en-US" sz="1100" dirty="0">
+                <a:solidFill>
+                  <a:srgbClr val="555555"/>
+                </a:solidFill>
+              </a:rPr>
+              <a:t>—</a:t>
+            </a:r>
+            <a:endParaRPr lang="en-US" sz="1100" dirty="0"/>
+          </a:p>
+        </p:txBody>
+      </p:sp>
+      <p:sp>
+        <p:nvSpPr>
+          <p:cNvPr id="70" name="Shape 68"/>
           <p:cNvSpPr/>
           <p:nvPr/>
         </p:nvSpPr>
         <p:spPr>
           <a:xfrm>
-            <a:off x="6720840" y="3831336"/>
-            <a:ext cx="2103120" cy="393192"/>
+            <a:off x="5349240" y="2651760"/>
+            <a:ext cx="1051560" cy="365760"/>
           </a:xfrm>
           <a:prstGeom prst="rect">
             <a:avLst/>
@@ -5929,14 +6149,14 @@
       </p:sp>
       <p:sp>
         <p:nvSpPr>
-          <p:cNvPr id="67" name="Text 65"/>
-          <p:cNvSpPr txBox="1"/>
-          <p:nvPr/>
-        </p:nvSpPr>
-        <p:spPr>
-          <a:xfrm>
-            <a:off x="6784848" y="3858768"/>
-            <a:ext cx="2011680" cy="338328"/>
+          <p:cNvPr id="71" name="Text 69"/>
+          <p:cNvSpPr txBox="1"/>
+          <p:nvPr/>
+        </p:nvSpPr>
+        <p:spPr>
+          <a:xfrm>
+            <a:off x="5404104" y="2670048"/>
+            <a:ext cx="960120" cy="329184"/>
           </a:xfrm>
           <a:prstGeom prst="rect">
             <a:avLst/>
@@ -5952,51 +6172,37 @@
               <a:buNone/>
             </a:pPr>
             <a:r>
-              <a:rPr lang="en-US" sz="1200" dirty="0">
-                <a:solidFill>
-                  <a:srgbClr val="FFFFFF"/>
-                </a:solidFill>
-              </a:rPr>
-              <a:t>$1,500K</a:t>
-            </a:r>
-            <a:endParaRPr lang="en-US" sz="1200" dirty="0"/>
-          </a:p>
-          <a:p>
-            <a:pPr algn="ctr" indent="0" marL="0">
-              <a:buNone/>
-            </a:pPr>
-            <a:r>
-              <a:rPr lang="en-US" sz="1200" dirty="0">
-                <a:solidFill>
-                  <a:srgbClr val="FFFFFF"/>
-                </a:solidFill>
-              </a:rPr>
-              <a:t>(0.50%)</a:t>
-            </a:r>
-            <a:endParaRPr lang="en-US" sz="1200" dirty="0"/>
-          </a:p>
-        </p:txBody>
-      </p:sp>
-      <p:sp>
-        <p:nvSpPr>
-          <p:cNvPr id="68" name="Shape 66"/>
+              <a:rPr lang="en-US" sz="1100" dirty="0">
+                <a:solidFill>
+                  <a:srgbClr val="555555"/>
+                </a:solidFill>
+              </a:rPr>
+              <a:t>—</a:t>
+            </a:r>
+            <a:endParaRPr lang="en-US" sz="1100" dirty="0"/>
+          </a:p>
+        </p:txBody>
+      </p:sp>
+      <p:sp>
+        <p:nvSpPr>
+          <p:cNvPr id="72" name="Shape 70"/>
           <p:cNvSpPr/>
           <p:nvPr/>
         </p:nvSpPr>
         <p:spPr>
           <a:xfrm>
-            <a:off x="320040" y="4270248"/>
-            <a:ext cx="8503920" cy="658368"/>
-          </a:xfrm>
-          <a:prstGeom prst="rect">
-            <a:avLst/>
-          </a:prstGeom>
-          <a:solidFill>
-            <a:srgbClr val="150B00"/>
+            <a:off x="6446520" y="2651760"/>
+            <a:ext cx="1051560" cy="365760"/>
+          </a:xfrm>
+          <a:prstGeom prst="rect">
+            <a:avLst/>
+          </a:prstGeom>
+          <a:solidFill>
+            <a:srgbClr val="1C1C1C"/>
           </a:solidFill>
           <a:ln w="12700">
             <a:solidFill>
-              <a:srgbClr val="F26A21"/>
+              <a:srgbClr val="2A2A2A"/>
             </a:solidFill>
             <a:prstDash val="solid"/>
           </a:ln>
@@ -6004,14 +6210,14 @@
       </p:sp>
       <p:sp>
         <p:nvSpPr>
-          <p:cNvPr id="69" name="Text 67"/>
-          <p:cNvSpPr txBox="1"/>
-          <p:nvPr/>
-        </p:nvSpPr>
-        <p:spPr>
-          <a:xfrm>
-            <a:off x="457200" y="4325112"/>
-            <a:ext cx="8229600" cy="548640"/>
+          <p:cNvPr id="73" name="Text 71"/>
+          <p:cNvSpPr txBox="1"/>
+          <p:nvPr/>
+        </p:nvSpPr>
+        <p:spPr>
+          <a:xfrm>
+            <a:off x="6501384" y="2670048"/>
+            <a:ext cx="960120" cy="329184"/>
           </a:xfrm>
           <a:prstGeom prst="rect">
             <a:avLst/>
@@ -6027,20 +6233,1241 @@
               <a:buNone/>
             </a:pPr>
             <a:r>
-              <a:rPr lang="en-US" sz="1200" i="1" dirty="0">
+              <a:rPr lang="en-US" sz="1100" dirty="0">
+                <a:solidFill>
+                  <a:srgbClr val="2ECC71"/>
+                </a:solidFill>
+              </a:rPr>
+              <a:t>✓</a:t>
+            </a:r>
+            <a:endParaRPr lang="en-US" sz="1100" dirty="0"/>
+          </a:p>
+        </p:txBody>
+      </p:sp>
+      <p:sp>
+        <p:nvSpPr>
+          <p:cNvPr id="74" name="Shape 72"/>
+          <p:cNvSpPr/>
+          <p:nvPr/>
+        </p:nvSpPr>
+        <p:spPr>
+          <a:xfrm>
+            <a:off x="7543800" y="2651760"/>
+            <a:ext cx="1005840" cy="365760"/>
+          </a:xfrm>
+          <a:prstGeom prst="rect">
+            <a:avLst/>
+          </a:prstGeom>
+          <a:solidFill>
+            <a:srgbClr val="1C1C1C"/>
+          </a:solidFill>
+          <a:ln w="12700">
+            <a:solidFill>
+              <a:srgbClr val="2A2A2A"/>
+            </a:solidFill>
+            <a:prstDash val="solid"/>
+          </a:ln>
+        </p:spPr>
+      </p:sp>
+      <p:sp>
+        <p:nvSpPr>
+          <p:cNvPr id="75" name="Text 73"/>
+          <p:cNvSpPr txBox="1"/>
+          <p:nvPr/>
+        </p:nvSpPr>
+        <p:spPr>
+          <a:xfrm>
+            <a:off x="7598664" y="2670048"/>
+            <a:ext cx="914400" cy="329184"/>
+          </a:xfrm>
+          <a:prstGeom prst="rect">
+            <a:avLst/>
+          </a:prstGeom>
+          <a:noFill/>
+          <a:ln/>
+        </p:spPr>
+        <p:txBody>
+          <a:bodyPr wrap="square" rtlCol="0" anchor="ctr"/>
+          <a:lstStyle/>
+          <a:p>
+            <a:pPr algn="ctr" indent="0" marL="0">
+              <a:buNone/>
+            </a:pPr>
+            <a:r>
+              <a:rPr lang="en-US" sz="1100" dirty="0">
+                <a:solidFill>
+                  <a:srgbClr val="FFFFFF"/>
+                </a:solidFill>
+              </a:rPr>
+              <a:t>Est. FY31</a:t>
+            </a:r>
+            <a:endParaRPr lang="en-US" sz="1100" dirty="0"/>
+          </a:p>
+        </p:txBody>
+      </p:sp>
+      <p:sp>
+        <p:nvSpPr>
+          <p:cNvPr id="76" name="Shape 74"/>
+          <p:cNvSpPr/>
+          <p:nvPr/>
+        </p:nvSpPr>
+        <p:spPr>
+          <a:xfrm>
+            <a:off x="274320" y="3017520"/>
+            <a:ext cx="2011680" cy="365760"/>
+          </a:xfrm>
+          <a:prstGeom prst="rect">
+            <a:avLst/>
+          </a:prstGeom>
+          <a:solidFill>
+            <a:srgbClr val="1A2035"/>
+          </a:solidFill>
+          <a:ln w="12700">
+            <a:solidFill>
+              <a:srgbClr val="2A2A2A"/>
+            </a:solidFill>
+            <a:prstDash val="solid"/>
+          </a:ln>
+        </p:spPr>
+      </p:sp>
+      <p:sp>
+        <p:nvSpPr>
+          <p:cNvPr id="77" name="Text 75"/>
+          <p:cNvSpPr txBox="1"/>
+          <p:nvPr/>
+        </p:nvSpPr>
+        <p:spPr>
+          <a:xfrm>
+            <a:off x="329184" y="3035808"/>
+            <a:ext cx="1920240" cy="329184"/>
+          </a:xfrm>
+          <a:prstGeom prst="rect">
+            <a:avLst/>
+          </a:prstGeom>
+          <a:noFill/>
+          <a:ln/>
+        </p:spPr>
+        <p:txBody>
+          <a:bodyPr wrap="square" rtlCol="0" anchor="ctr"/>
+          <a:lstStyle/>
+          <a:p>
+            <a:pPr algn="l" indent="0" marL="0">
+              <a:buNone/>
+            </a:pPr>
+            <a:r>
+              <a:rPr lang="en-US" sz="900" dirty="0">
                 <a:solidFill>
                   <a:srgbClr val="CCCCCC"/>
                 </a:solidFill>
               </a:rPr>
-              <a:t>"The up-front price reflects what the numbers support today; the earn-outs are how that value grows as goals are met."  — John M. Quinn</a:t>
-            </a:r>
-            <a:endParaRPr lang="en-US" sz="1200" dirty="0"/>
+              <a:t>M5  BLK3 tank qualification  →$200K</a:t>
+            </a:r>
+            <a:endParaRPr lang="en-US" sz="900" dirty="0"/>
+          </a:p>
+        </p:txBody>
+      </p:sp>
+      <p:sp>
+        <p:nvSpPr>
+          <p:cNvPr id="78" name="Shape 76"/>
+          <p:cNvSpPr/>
+          <p:nvPr/>
+        </p:nvSpPr>
+        <p:spPr>
+          <a:xfrm>
+            <a:off x="2331720" y="3017520"/>
+            <a:ext cx="1874520" cy="365760"/>
+          </a:xfrm>
+          <a:prstGeom prst="rect">
+            <a:avLst/>
+          </a:prstGeom>
+          <a:solidFill>
+            <a:srgbClr val="1A2035"/>
+          </a:solidFill>
+          <a:ln w="12700">
+            <a:solidFill>
+              <a:srgbClr val="2A2A2A"/>
+            </a:solidFill>
+            <a:prstDash val="solid"/>
+          </a:ln>
+        </p:spPr>
+      </p:sp>
+      <p:sp>
+        <p:nvSpPr>
+          <p:cNvPr id="79" name="Text 77"/>
+          <p:cNvSpPr txBox="1"/>
+          <p:nvPr/>
+        </p:nvSpPr>
+        <p:spPr>
+          <a:xfrm>
+            <a:off x="2386584" y="3035808"/>
+            <a:ext cx="1783080" cy="329184"/>
+          </a:xfrm>
+          <a:prstGeom prst="rect">
+            <a:avLst/>
+          </a:prstGeom>
+          <a:noFill/>
+          <a:ln/>
+        </p:spPr>
+        <p:txBody>
+          <a:bodyPr wrap="square" rtlCol="0" anchor="ctr"/>
+          <a:lstStyle/>
+          <a:p>
+            <a:pPr algn="l" indent="0" marL="0">
+              <a:buNone/>
+            </a:pPr>
+            <a:r>
+              <a:rPr lang="en-US" sz="900" dirty="0">
+                <a:solidFill>
+                  <a:srgbClr val="CCCCCC"/>
+                </a:solidFill>
+              </a:rPr>
+              <a:t>Exos BLK3 tank cert complete</a:t>
+            </a:r>
+            <a:endParaRPr lang="en-US" sz="900" dirty="0"/>
+          </a:p>
+        </p:txBody>
+      </p:sp>
+      <p:sp>
+        <p:nvSpPr>
+          <p:cNvPr id="80" name="Shape 78"/>
+          <p:cNvSpPr/>
+          <p:nvPr/>
+        </p:nvSpPr>
+        <p:spPr>
+          <a:xfrm>
+            <a:off x="4251960" y="3017520"/>
+            <a:ext cx="1051560" cy="365760"/>
+          </a:xfrm>
+          <a:prstGeom prst="rect">
+            <a:avLst/>
+          </a:prstGeom>
+          <a:solidFill>
+            <a:srgbClr val="1A2035"/>
+          </a:solidFill>
+          <a:ln w="12700">
+            <a:solidFill>
+              <a:srgbClr val="2A2A2A"/>
+            </a:solidFill>
+            <a:prstDash val="solid"/>
+          </a:ln>
+        </p:spPr>
+      </p:sp>
+      <p:sp>
+        <p:nvSpPr>
+          <p:cNvPr id="81" name="Text 79"/>
+          <p:cNvSpPr txBox="1"/>
+          <p:nvPr/>
+        </p:nvSpPr>
+        <p:spPr>
+          <a:xfrm>
+            <a:off x="4306824" y="3035808"/>
+            <a:ext cx="960120" cy="329184"/>
+          </a:xfrm>
+          <a:prstGeom prst="rect">
+            <a:avLst/>
+          </a:prstGeom>
+          <a:noFill/>
+          <a:ln/>
+        </p:spPr>
+        <p:txBody>
+          <a:bodyPr wrap="square" rtlCol="0" anchor="ctr"/>
+          <a:lstStyle/>
+          <a:p>
+            <a:pPr algn="ctr" indent="0" marL="0">
+              <a:buNone/>
+            </a:pPr>
+            <a:r>
+              <a:rPr lang="en-US" sz="1100" dirty="0">
+                <a:solidFill>
+                  <a:srgbClr val="555555"/>
+                </a:solidFill>
+              </a:rPr>
+              <a:t>—</a:t>
+            </a:r>
+            <a:endParaRPr lang="en-US" sz="1100" dirty="0"/>
+          </a:p>
+        </p:txBody>
+      </p:sp>
+      <p:sp>
+        <p:nvSpPr>
+          <p:cNvPr id="82" name="Shape 80"/>
+          <p:cNvSpPr/>
+          <p:nvPr/>
+        </p:nvSpPr>
+        <p:spPr>
+          <a:xfrm>
+            <a:off x="5349240" y="3017520"/>
+            <a:ext cx="1051560" cy="365760"/>
+          </a:xfrm>
+          <a:prstGeom prst="rect">
+            <a:avLst/>
+          </a:prstGeom>
+          <a:solidFill>
+            <a:srgbClr val="1A2035"/>
+          </a:solidFill>
+          <a:ln w="12700">
+            <a:solidFill>
+              <a:srgbClr val="2A2A2A"/>
+            </a:solidFill>
+            <a:prstDash val="solid"/>
+          </a:ln>
+        </p:spPr>
+      </p:sp>
+      <p:sp>
+        <p:nvSpPr>
+          <p:cNvPr id="83" name="Text 81"/>
+          <p:cNvSpPr txBox="1"/>
+          <p:nvPr/>
+        </p:nvSpPr>
+        <p:spPr>
+          <a:xfrm>
+            <a:off x="5404104" y="3035808"/>
+            <a:ext cx="960120" cy="329184"/>
+          </a:xfrm>
+          <a:prstGeom prst="rect">
+            <a:avLst/>
+          </a:prstGeom>
+          <a:noFill/>
+          <a:ln/>
+        </p:spPr>
+        <p:txBody>
+          <a:bodyPr wrap="square" rtlCol="0" anchor="ctr"/>
+          <a:lstStyle/>
+          <a:p>
+            <a:pPr algn="ctr" indent="0" marL="0">
+              <a:buNone/>
+            </a:pPr>
+            <a:r>
+              <a:rPr lang="en-US" sz="1100" dirty="0">
+                <a:solidFill>
+                  <a:srgbClr val="555555"/>
+                </a:solidFill>
+              </a:rPr>
+              <a:t>—</a:t>
+            </a:r>
+            <a:endParaRPr lang="en-US" sz="1100" dirty="0"/>
+          </a:p>
+        </p:txBody>
+      </p:sp>
+      <p:sp>
+        <p:nvSpPr>
+          <p:cNvPr id="84" name="Shape 82"/>
+          <p:cNvSpPr/>
+          <p:nvPr/>
+        </p:nvSpPr>
+        <p:spPr>
+          <a:xfrm>
+            <a:off x="6446520" y="3017520"/>
+            <a:ext cx="1051560" cy="365760"/>
+          </a:xfrm>
+          <a:prstGeom prst="rect">
+            <a:avLst/>
+          </a:prstGeom>
+          <a:solidFill>
+            <a:srgbClr val="1A2035"/>
+          </a:solidFill>
+          <a:ln w="12700">
+            <a:solidFill>
+              <a:srgbClr val="2A2A2A"/>
+            </a:solidFill>
+            <a:prstDash val="solid"/>
+          </a:ln>
+        </p:spPr>
+      </p:sp>
+      <p:sp>
+        <p:nvSpPr>
+          <p:cNvPr id="85" name="Text 83"/>
+          <p:cNvSpPr txBox="1"/>
+          <p:nvPr/>
+        </p:nvSpPr>
+        <p:spPr>
+          <a:xfrm>
+            <a:off x="6501384" y="3035808"/>
+            <a:ext cx="960120" cy="329184"/>
+          </a:xfrm>
+          <a:prstGeom prst="rect">
+            <a:avLst/>
+          </a:prstGeom>
+          <a:noFill/>
+          <a:ln/>
+        </p:spPr>
+        <p:txBody>
+          <a:bodyPr wrap="square" rtlCol="0" anchor="ctr"/>
+          <a:lstStyle/>
+          <a:p>
+            <a:pPr algn="ctr" indent="0" marL="0">
+              <a:buNone/>
+            </a:pPr>
+            <a:r>
+              <a:rPr lang="en-US" sz="1100" dirty="0">
+                <a:solidFill>
+                  <a:srgbClr val="2ECC71"/>
+                </a:solidFill>
+              </a:rPr>
+              <a:t>✓</a:t>
+            </a:r>
+            <a:endParaRPr lang="en-US" sz="1100" dirty="0"/>
+          </a:p>
+        </p:txBody>
+      </p:sp>
+      <p:sp>
+        <p:nvSpPr>
+          <p:cNvPr id="86" name="Shape 84"/>
+          <p:cNvSpPr/>
+          <p:nvPr/>
+        </p:nvSpPr>
+        <p:spPr>
+          <a:xfrm>
+            <a:off x="7543800" y="3017520"/>
+            <a:ext cx="1005840" cy="365760"/>
+          </a:xfrm>
+          <a:prstGeom prst="rect">
+            <a:avLst/>
+          </a:prstGeom>
+          <a:solidFill>
+            <a:srgbClr val="1A2035"/>
+          </a:solidFill>
+          <a:ln w="12700">
+            <a:solidFill>
+              <a:srgbClr val="2A2A2A"/>
+            </a:solidFill>
+            <a:prstDash val="solid"/>
+          </a:ln>
+        </p:spPr>
+      </p:sp>
+      <p:sp>
+        <p:nvSpPr>
+          <p:cNvPr id="87" name="Text 85"/>
+          <p:cNvSpPr txBox="1"/>
+          <p:nvPr/>
+        </p:nvSpPr>
+        <p:spPr>
+          <a:xfrm>
+            <a:off x="7598664" y="3035808"/>
+            <a:ext cx="914400" cy="329184"/>
+          </a:xfrm>
+          <a:prstGeom prst="rect">
+            <a:avLst/>
+          </a:prstGeom>
+          <a:noFill/>
+          <a:ln/>
+        </p:spPr>
+        <p:txBody>
+          <a:bodyPr wrap="square" rtlCol="0" anchor="ctr"/>
+          <a:lstStyle/>
+          <a:p>
+            <a:pPr algn="ctr" indent="0" marL="0">
+              <a:buNone/>
+            </a:pPr>
+            <a:r>
+              <a:rPr lang="en-US" sz="1100" dirty="0">
+                <a:solidFill>
+                  <a:srgbClr val="FFFFFF"/>
+                </a:solidFill>
+              </a:rPr>
+              <a:t>Est. FY27–28</a:t>
+            </a:r>
+            <a:endParaRPr lang="en-US" sz="1100" dirty="0"/>
+          </a:p>
+        </p:txBody>
+      </p:sp>
+      <p:sp>
+        <p:nvSpPr>
+          <p:cNvPr id="88" name="Shape 86"/>
+          <p:cNvSpPr/>
+          <p:nvPr/>
+        </p:nvSpPr>
+        <p:spPr>
+          <a:xfrm>
+            <a:off x="274320" y="3383280"/>
+            <a:ext cx="2011680" cy="457200"/>
+          </a:xfrm>
+          <a:prstGeom prst="rect">
+            <a:avLst/>
+          </a:prstGeom>
+          <a:solidFill>
+            <a:srgbClr val="1C1C1C"/>
+          </a:solidFill>
+          <a:ln w="12700">
+            <a:solidFill>
+              <a:srgbClr val="2A2A2A"/>
+            </a:solidFill>
+            <a:prstDash val="solid"/>
+          </a:ln>
+        </p:spPr>
+      </p:sp>
+      <p:sp>
+        <p:nvSpPr>
+          <p:cNvPr id="89" name="Text 87"/>
+          <p:cNvSpPr txBox="1"/>
+          <p:nvPr/>
+        </p:nvSpPr>
+        <p:spPr>
+          <a:xfrm>
+            <a:off x="329184" y="3401568"/>
+            <a:ext cx="1920240" cy="420624"/>
+          </a:xfrm>
+          <a:prstGeom prst="rect">
+            <a:avLst/>
+          </a:prstGeom>
+          <a:noFill/>
+          <a:ln/>
+        </p:spPr>
+        <p:txBody>
+          <a:bodyPr wrap="square" rtlCol="0" anchor="ctr"/>
+          <a:lstStyle/>
+          <a:p>
+            <a:pPr algn="l" indent="0" marL="0">
+              <a:buNone/>
+            </a:pPr>
+            <a:r>
+              <a:rPr lang="en-US" sz="900" dirty="0">
+                <a:solidFill>
+                  <a:srgbClr val="CCCCCC"/>
+                </a:solidFill>
+              </a:rPr>
+              <a:t>Exos stock earn-out at RTO listing</a:t>
+            </a:r>
+            <a:endParaRPr lang="en-US" sz="900" dirty="0"/>
+          </a:p>
+          <a:p>
+            <a:pPr algn="l" indent="0" marL="0">
+              <a:buNone/>
+            </a:pPr>
+            <a:r>
+              <a:rPr lang="en-US" sz="900" dirty="0">
+                <a:solidFill>
+                  <a:srgbClr val="CCCCCC"/>
+                </a:solidFill>
+              </a:rPr>
+              <a:t>(adds to ~0.59% EAI up-front)</a:t>
+            </a:r>
+            <a:endParaRPr lang="en-US" sz="900" dirty="0"/>
+          </a:p>
+        </p:txBody>
+      </p:sp>
+      <p:sp>
+        <p:nvSpPr>
+          <p:cNvPr id="90" name="Shape 88"/>
+          <p:cNvSpPr/>
+          <p:nvPr/>
+        </p:nvSpPr>
+        <p:spPr>
+          <a:xfrm>
+            <a:off x="2331720" y="3383280"/>
+            <a:ext cx="1874520" cy="457200"/>
+          </a:xfrm>
+          <a:prstGeom prst="rect">
+            <a:avLst/>
+          </a:prstGeom>
+          <a:solidFill>
+            <a:srgbClr val="1C1C1C"/>
+          </a:solidFill>
+          <a:ln w="12700">
+            <a:solidFill>
+              <a:srgbClr val="2A2A2A"/>
+            </a:solidFill>
+            <a:prstDash val="solid"/>
+          </a:ln>
+        </p:spPr>
+      </p:sp>
+      <p:sp>
+        <p:nvSpPr>
+          <p:cNvPr id="91" name="Text 89"/>
+          <p:cNvSpPr txBox="1"/>
+          <p:nvPr/>
+        </p:nvSpPr>
+        <p:spPr>
+          <a:xfrm>
+            <a:off x="2386584" y="3401568"/>
+            <a:ext cx="1783080" cy="420624"/>
+          </a:xfrm>
+          <a:prstGeom prst="rect">
+            <a:avLst/>
+          </a:prstGeom>
+          <a:noFill/>
+          <a:ln/>
+        </p:spPr>
+        <p:txBody>
+          <a:bodyPr wrap="square" rtlCol="0" anchor="ctr"/>
+          <a:lstStyle/>
+          <a:p>
+            <a:pPr algn="l" indent="0" marL="0">
+              <a:buNone/>
+            </a:pPr>
+            <a:r>
+              <a:rPr lang="en-US" sz="900" dirty="0">
+                <a:solidFill>
+                  <a:srgbClr val="CCCCCC"/>
+                </a:solidFill>
+              </a:rPr>
+              <a:t>Issued at RTO listing</a:t>
+            </a:r>
+            <a:endParaRPr lang="en-US" sz="900" dirty="0"/>
+          </a:p>
+        </p:txBody>
+      </p:sp>
+      <p:sp>
+        <p:nvSpPr>
+          <p:cNvPr id="92" name="Shape 90"/>
+          <p:cNvSpPr/>
+          <p:nvPr/>
+        </p:nvSpPr>
+        <p:spPr>
+          <a:xfrm>
+            <a:off x="4251960" y="3383280"/>
+            <a:ext cx="1051560" cy="457200"/>
+          </a:xfrm>
+          <a:prstGeom prst="rect">
+            <a:avLst/>
+          </a:prstGeom>
+          <a:solidFill>
+            <a:srgbClr val="1C1C1C"/>
+          </a:solidFill>
+          <a:ln w="12700">
+            <a:solidFill>
+              <a:srgbClr val="2A2A2A"/>
+            </a:solidFill>
+            <a:prstDash val="solid"/>
+          </a:ln>
+        </p:spPr>
+      </p:sp>
+      <p:sp>
+        <p:nvSpPr>
+          <p:cNvPr id="93" name="Text 91"/>
+          <p:cNvSpPr txBox="1"/>
+          <p:nvPr/>
+        </p:nvSpPr>
+        <p:spPr>
+          <a:xfrm>
+            <a:off x="4306824" y="3401568"/>
+            <a:ext cx="960120" cy="420624"/>
+          </a:xfrm>
+          <a:prstGeom prst="rect">
+            <a:avLst/>
+          </a:prstGeom>
+          <a:noFill/>
+          <a:ln/>
+        </p:spPr>
+        <p:txBody>
+          <a:bodyPr wrap="square" rtlCol="0" anchor="ctr"/>
+          <a:lstStyle/>
+          <a:p>
+            <a:pPr algn="ctr" indent="0" marL="0">
+              <a:buNone/>
+            </a:pPr>
+            <a:r>
+              <a:rPr lang="en-US" sz="1100" dirty="0">
+                <a:solidFill>
+                  <a:srgbClr val="FFFFFF"/>
+                </a:solidFill>
+              </a:rPr>
+              <a:t>$0</a:t>
+            </a:r>
+            <a:endParaRPr lang="en-US" sz="1100" dirty="0"/>
+          </a:p>
+          <a:p>
+            <a:pPr algn="ctr" indent="0" marL="0">
+              <a:buNone/>
+            </a:pPr>
+            <a:r>
+              <a:rPr lang="en-US" sz="1100" dirty="0">
+                <a:solidFill>
+                  <a:srgbClr val="FFFFFF"/>
+                </a:solidFill>
+              </a:rPr>
+              <a:t>(0.0%)</a:t>
+            </a:r>
+            <a:endParaRPr lang="en-US" sz="1100" dirty="0"/>
+          </a:p>
+        </p:txBody>
+      </p:sp>
+      <p:sp>
+        <p:nvSpPr>
+          <p:cNvPr id="94" name="Shape 92"/>
+          <p:cNvSpPr/>
+          <p:nvPr/>
+        </p:nvSpPr>
+        <p:spPr>
+          <a:xfrm>
+            <a:off x="5349240" y="3383280"/>
+            <a:ext cx="1051560" cy="457200"/>
+          </a:xfrm>
+          <a:prstGeom prst="rect">
+            <a:avLst/>
+          </a:prstGeom>
+          <a:solidFill>
+            <a:srgbClr val="1C1C1C"/>
+          </a:solidFill>
+          <a:ln w="12700">
+            <a:solidFill>
+              <a:srgbClr val="2A2A2A"/>
+            </a:solidFill>
+            <a:prstDash val="solid"/>
+          </a:ln>
+        </p:spPr>
+      </p:sp>
+      <p:sp>
+        <p:nvSpPr>
+          <p:cNvPr id="95" name="Text 93"/>
+          <p:cNvSpPr txBox="1"/>
+          <p:nvPr/>
+        </p:nvSpPr>
+        <p:spPr>
+          <a:xfrm>
+            <a:off x="5404104" y="3401568"/>
+            <a:ext cx="960120" cy="420624"/>
+          </a:xfrm>
+          <a:prstGeom prst="rect">
+            <a:avLst/>
+          </a:prstGeom>
+          <a:noFill/>
+          <a:ln/>
+        </p:spPr>
+        <p:txBody>
+          <a:bodyPr wrap="square" rtlCol="0" anchor="ctr"/>
+          <a:lstStyle/>
+          <a:p>
+            <a:pPr algn="ctr" indent="0" marL="0">
+              <a:buNone/>
+            </a:pPr>
+            <a:r>
+              <a:rPr lang="en-US" sz="1100" dirty="0">
+                <a:solidFill>
+                  <a:srgbClr val="FFFFFF"/>
+                </a:solidFill>
+              </a:rPr>
+              <a:t>$625K</a:t>
+            </a:r>
+            <a:endParaRPr lang="en-US" sz="1100" dirty="0"/>
+          </a:p>
+          <a:p>
+            <a:pPr algn="ctr" indent="0" marL="0">
+              <a:buNone/>
+            </a:pPr>
+            <a:r>
+              <a:rPr lang="en-US" sz="1100" dirty="0">
+                <a:solidFill>
+                  <a:srgbClr val="FFFFFF"/>
+                </a:solidFill>
+              </a:rPr>
+              <a:t>(0.25%)</a:t>
+            </a:r>
+            <a:endParaRPr lang="en-US" sz="1100" dirty="0"/>
+          </a:p>
+        </p:txBody>
+      </p:sp>
+      <p:sp>
+        <p:nvSpPr>
+          <p:cNvPr id="96" name="Shape 94"/>
+          <p:cNvSpPr/>
+          <p:nvPr/>
+        </p:nvSpPr>
+        <p:spPr>
+          <a:xfrm>
+            <a:off x="6446520" y="3383280"/>
+            <a:ext cx="1051560" cy="457200"/>
+          </a:xfrm>
+          <a:prstGeom prst="rect">
+            <a:avLst/>
+          </a:prstGeom>
+          <a:solidFill>
+            <a:srgbClr val="1C1C1C"/>
+          </a:solidFill>
+          <a:ln w="12700">
+            <a:solidFill>
+              <a:srgbClr val="2A2A2A"/>
+            </a:solidFill>
+            <a:prstDash val="solid"/>
+          </a:ln>
+        </p:spPr>
+      </p:sp>
+      <p:sp>
+        <p:nvSpPr>
+          <p:cNvPr id="97" name="Text 95"/>
+          <p:cNvSpPr txBox="1"/>
+          <p:nvPr/>
+        </p:nvSpPr>
+        <p:spPr>
+          <a:xfrm>
+            <a:off x="6501384" y="3401568"/>
+            <a:ext cx="960120" cy="420624"/>
+          </a:xfrm>
+          <a:prstGeom prst="rect">
+            <a:avLst/>
+          </a:prstGeom>
+          <a:noFill/>
+          <a:ln/>
+        </p:spPr>
+        <p:txBody>
+          <a:bodyPr wrap="square" rtlCol="0" anchor="ctr"/>
+          <a:lstStyle/>
+          <a:p>
+            <a:pPr algn="ctr" indent="0" marL="0">
+              <a:buNone/>
+            </a:pPr>
+            <a:r>
+              <a:rPr lang="en-US" sz="1100" dirty="0">
+                <a:solidFill>
+                  <a:srgbClr val="FFFFFF"/>
+                </a:solidFill>
+              </a:rPr>
+              <a:t>$1,500K</a:t>
+            </a:r>
+            <a:endParaRPr lang="en-US" sz="1100" dirty="0"/>
+          </a:p>
+          <a:p>
+            <a:pPr algn="ctr" indent="0" marL="0">
+              <a:buNone/>
+            </a:pPr>
+            <a:r>
+              <a:rPr lang="en-US" sz="1100" dirty="0">
+                <a:solidFill>
+                  <a:srgbClr val="FFFFFF"/>
+                </a:solidFill>
+              </a:rPr>
+              <a:t>(0.50%)</a:t>
+            </a:r>
+            <a:endParaRPr lang="en-US" sz="1100" dirty="0"/>
+          </a:p>
+        </p:txBody>
+      </p:sp>
+      <p:sp>
+        <p:nvSpPr>
+          <p:cNvPr id="98" name="Shape 96"/>
+          <p:cNvSpPr/>
+          <p:nvPr/>
+        </p:nvSpPr>
+        <p:spPr>
+          <a:xfrm>
+            <a:off x="7543800" y="3383280"/>
+            <a:ext cx="1005840" cy="457200"/>
+          </a:xfrm>
+          <a:prstGeom prst="rect">
+            <a:avLst/>
+          </a:prstGeom>
+          <a:solidFill>
+            <a:srgbClr val="1C1C1C"/>
+          </a:solidFill>
+          <a:ln w="12700">
+            <a:solidFill>
+              <a:srgbClr val="2A2A2A"/>
+            </a:solidFill>
+            <a:prstDash val="solid"/>
+          </a:ln>
+        </p:spPr>
+      </p:sp>
+      <p:sp>
+        <p:nvSpPr>
+          <p:cNvPr id="99" name="Text 97"/>
+          <p:cNvSpPr txBox="1"/>
+          <p:nvPr/>
+        </p:nvSpPr>
+        <p:spPr>
+          <a:xfrm>
+            <a:off x="7598664" y="3401568"/>
+            <a:ext cx="914400" cy="420624"/>
+          </a:xfrm>
+          <a:prstGeom prst="rect">
+            <a:avLst/>
+          </a:prstGeom>
+          <a:noFill/>
+          <a:ln/>
+        </p:spPr>
+        <p:txBody>
+          <a:bodyPr wrap="square" rtlCol="0" anchor="ctr"/>
+          <a:lstStyle/>
+          <a:p>
+            <a:pPr algn="ctr" indent="0" marL="0">
+              <a:buNone/>
+            </a:pPr>
+            <a:r>
+              <a:rPr lang="en-US" sz="1100" dirty="0">
+                <a:solidFill>
+                  <a:srgbClr val="FFFFFF"/>
+                </a:solidFill>
+              </a:rPr>
+              <a:t>Post-RTO</a:t>
+            </a:r>
+            <a:endParaRPr lang="en-US" sz="1100" dirty="0"/>
+          </a:p>
+          <a:p>
+            <a:pPr algn="ctr" indent="0" marL="0">
+              <a:buNone/>
+            </a:pPr>
+            <a:r>
+              <a:rPr lang="en-US" sz="1100" dirty="0">
+                <a:solidFill>
+                  <a:srgbClr val="FFFFFF"/>
+                </a:solidFill>
+              </a:rPr>
+              <a:t>~FY29</a:t>
+            </a:r>
+            <a:endParaRPr lang="en-US" sz="1100" dirty="0"/>
+          </a:p>
+        </p:txBody>
+      </p:sp>
+      <p:sp>
+        <p:nvSpPr>
+          <p:cNvPr id="100" name="Shape 98"/>
+          <p:cNvSpPr/>
+          <p:nvPr/>
+        </p:nvSpPr>
+        <p:spPr>
+          <a:xfrm>
+            <a:off x="274320" y="3840480"/>
+            <a:ext cx="2011680" cy="384048"/>
+          </a:xfrm>
+          <a:prstGeom prst="rect">
+            <a:avLst/>
+          </a:prstGeom>
+          <a:solidFill>
+            <a:srgbClr val="0A2800"/>
+          </a:solidFill>
+          <a:ln w="12700">
+            <a:solidFill>
+              <a:srgbClr val="2A2A2A"/>
+            </a:solidFill>
+            <a:prstDash val="solid"/>
+          </a:ln>
+        </p:spPr>
+      </p:sp>
+      <p:sp>
+        <p:nvSpPr>
+          <p:cNvPr id="101" name="Text 99"/>
+          <p:cNvSpPr txBox="1"/>
+          <p:nvPr/>
+        </p:nvSpPr>
+        <p:spPr>
+          <a:xfrm>
+            <a:off x="329184" y="3858768"/>
+            <a:ext cx="1920240" cy="347472"/>
+          </a:xfrm>
+          <a:prstGeom prst="rect">
+            <a:avLst/>
+          </a:prstGeom>
+          <a:noFill/>
+          <a:ln/>
+        </p:spPr>
+        <p:txBody>
+          <a:bodyPr wrap="square" rtlCol="0" anchor="ctr"/>
+          <a:lstStyle/>
+          <a:p>
+            <a:pPr algn="l" indent="0" marL="0">
+              <a:buNone/>
+            </a:pPr>
+            <a:r>
+              <a:rPr lang="en-US" sz="900" b="1" dirty="0">
+                <a:solidFill>
+                  <a:srgbClr val="CCCCCC"/>
+                </a:solidFill>
+              </a:rPr>
+              <a:t>TOTAL EARN-OUTS  (③ minus ②)</a:t>
+            </a:r>
+            <a:endParaRPr lang="en-US" sz="900" dirty="0"/>
+          </a:p>
+        </p:txBody>
+      </p:sp>
+      <p:sp>
+        <p:nvSpPr>
+          <p:cNvPr id="102" name="Shape 100"/>
+          <p:cNvSpPr/>
+          <p:nvPr/>
+        </p:nvSpPr>
+        <p:spPr>
+          <a:xfrm>
+            <a:off x="2331720" y="3840480"/>
+            <a:ext cx="1874520" cy="384048"/>
+          </a:xfrm>
+          <a:prstGeom prst="rect">
+            <a:avLst/>
+          </a:prstGeom>
+          <a:solidFill>
+            <a:srgbClr val="0A2800"/>
+          </a:solidFill>
+          <a:ln w="12700">
+            <a:solidFill>
+              <a:srgbClr val="2A2A2A"/>
+            </a:solidFill>
+            <a:prstDash val="solid"/>
+          </a:ln>
+        </p:spPr>
+      </p:sp>
+      <p:sp>
+        <p:nvSpPr>
+          <p:cNvPr id="103" name="Text 101"/>
+          <p:cNvSpPr txBox="1"/>
+          <p:nvPr/>
+        </p:nvSpPr>
+        <p:spPr>
+          <a:xfrm>
+            <a:off x="2386584" y="3858768"/>
+            <a:ext cx="1783080" cy="347472"/>
+          </a:xfrm>
+          <a:prstGeom prst="rect">
+            <a:avLst/>
+          </a:prstGeom>
+          <a:noFill/>
+          <a:ln/>
+        </p:spPr>
+        <p:txBody>
+          <a:bodyPr wrap="square" rtlCol="0" anchor="ctr"/>
+          <a:lstStyle/>
+          <a:p>
+            <a:pPr algn="l" indent="0" marL="0">
+              <a:buNone/>
+            </a:pPr>
+            <a:endParaRPr lang="en-US" sz="900" dirty="0"/>
+          </a:p>
+        </p:txBody>
+      </p:sp>
+      <p:sp>
+        <p:nvSpPr>
+          <p:cNvPr id="104" name="Shape 102"/>
+          <p:cNvSpPr/>
+          <p:nvPr/>
+        </p:nvSpPr>
+        <p:spPr>
+          <a:xfrm>
+            <a:off x="4251960" y="3840480"/>
+            <a:ext cx="1051560" cy="384048"/>
+          </a:xfrm>
+          <a:prstGeom prst="rect">
+            <a:avLst/>
+          </a:prstGeom>
+          <a:solidFill>
+            <a:srgbClr val="0A2800"/>
+          </a:solidFill>
+          <a:ln w="12700">
+            <a:solidFill>
+              <a:srgbClr val="2A2A2A"/>
+            </a:solidFill>
+            <a:prstDash val="solid"/>
+          </a:ln>
+        </p:spPr>
+      </p:sp>
+      <p:sp>
+        <p:nvSpPr>
+          <p:cNvPr id="105" name="Text 103"/>
+          <p:cNvSpPr txBox="1"/>
+          <p:nvPr/>
+        </p:nvSpPr>
+        <p:spPr>
+          <a:xfrm>
+            <a:off x="4306824" y="3858768"/>
+            <a:ext cx="960120" cy="347472"/>
+          </a:xfrm>
+          <a:prstGeom prst="rect">
+            <a:avLst/>
+          </a:prstGeom>
+          <a:noFill/>
+          <a:ln/>
+        </p:spPr>
+        <p:txBody>
+          <a:bodyPr wrap="square" rtlCol="0" anchor="ctr"/>
+          <a:lstStyle/>
+          <a:p>
+            <a:pPr algn="ctr" indent="0" marL="0">
+              <a:buNone/>
+            </a:pPr>
+            <a:r>
+              <a:rPr lang="en-US" sz="1100" b="1" dirty="0">
+                <a:solidFill>
+                  <a:srgbClr val="2ECC71"/>
+                </a:solidFill>
+              </a:rPr>
+              <a:t>$950K</a:t>
+            </a:r>
+            <a:endParaRPr lang="en-US" sz="1100" dirty="0"/>
+          </a:p>
+        </p:txBody>
+      </p:sp>
+      <p:sp>
+        <p:nvSpPr>
+          <p:cNvPr id="106" name="Shape 104"/>
+          <p:cNvSpPr/>
+          <p:nvPr/>
+        </p:nvSpPr>
+        <p:spPr>
+          <a:xfrm>
+            <a:off x="5349240" y="3840480"/>
+            <a:ext cx="1051560" cy="384048"/>
+          </a:xfrm>
+          <a:prstGeom prst="rect">
+            <a:avLst/>
+          </a:prstGeom>
+          <a:solidFill>
+            <a:srgbClr val="0A2800"/>
+          </a:solidFill>
+          <a:ln w="12700">
+            <a:solidFill>
+              <a:srgbClr val="2A2A2A"/>
+            </a:solidFill>
+            <a:prstDash val="solid"/>
+          </a:ln>
+        </p:spPr>
+      </p:sp>
+      <p:sp>
+        <p:nvSpPr>
+          <p:cNvPr id="107" name="Text 105"/>
+          <p:cNvSpPr txBox="1"/>
+          <p:nvPr/>
+        </p:nvSpPr>
+        <p:spPr>
+          <a:xfrm>
+            <a:off x="5404104" y="3858768"/>
+            <a:ext cx="960120" cy="347472"/>
+          </a:xfrm>
+          <a:prstGeom prst="rect">
+            <a:avLst/>
+          </a:prstGeom>
+          <a:noFill/>
+          <a:ln/>
+        </p:spPr>
+        <p:txBody>
+          <a:bodyPr wrap="square" rtlCol="0" anchor="ctr"/>
+          <a:lstStyle/>
+          <a:p>
+            <a:pPr algn="ctr" indent="0" marL="0">
+              <a:buNone/>
+            </a:pPr>
+            <a:r>
+              <a:rPr lang="en-US" sz="1100" b="1" dirty="0">
+                <a:solidFill>
+                  <a:srgbClr val="2ECC71"/>
+                </a:solidFill>
+              </a:rPr>
+              <a:t>$2,525K</a:t>
+            </a:r>
+            <a:endParaRPr lang="en-US" sz="1100" dirty="0"/>
+          </a:p>
+        </p:txBody>
+      </p:sp>
+      <p:sp>
+        <p:nvSpPr>
+          <p:cNvPr id="108" name="Shape 106"/>
+          <p:cNvSpPr/>
+          <p:nvPr/>
+        </p:nvSpPr>
+        <p:spPr>
+          <a:xfrm>
+            <a:off x="6446520" y="3840480"/>
+            <a:ext cx="1051560" cy="384048"/>
+          </a:xfrm>
+          <a:prstGeom prst="rect">
+            <a:avLst/>
+          </a:prstGeom>
+          <a:solidFill>
+            <a:srgbClr val="0A2800"/>
+          </a:solidFill>
+          <a:ln w="12700">
+            <a:solidFill>
+              <a:srgbClr val="2A2A2A"/>
+            </a:solidFill>
+            <a:prstDash val="solid"/>
+          </a:ln>
+        </p:spPr>
+      </p:sp>
+      <p:sp>
+        <p:nvSpPr>
+          <p:cNvPr id="109" name="Text 107"/>
+          <p:cNvSpPr txBox="1"/>
+          <p:nvPr/>
+        </p:nvSpPr>
+        <p:spPr>
+          <a:xfrm>
+            <a:off x="6501384" y="3858768"/>
+            <a:ext cx="960120" cy="347472"/>
+          </a:xfrm>
+          <a:prstGeom prst="rect">
+            <a:avLst/>
+          </a:prstGeom>
+          <a:noFill/>
+          <a:ln/>
+        </p:spPr>
+        <p:txBody>
+          <a:bodyPr wrap="square" rtlCol="0" anchor="ctr"/>
+          <a:lstStyle/>
+          <a:p>
+            <a:pPr algn="ctr" indent="0" marL="0">
+              <a:buNone/>
+            </a:pPr>
+            <a:r>
+              <a:rPr lang="en-US" sz="1100" b="1" dirty="0">
+                <a:solidFill>
+                  <a:srgbClr val="2ECC71"/>
+                </a:solidFill>
+              </a:rPr>
+              <a:t>$4,100K</a:t>
+            </a:r>
+            <a:endParaRPr lang="en-US" sz="1100" dirty="0"/>
+          </a:p>
+        </p:txBody>
+      </p:sp>
+      <p:sp>
+        <p:nvSpPr>
+          <p:cNvPr id="110" name="Shape 108"/>
+          <p:cNvSpPr/>
+          <p:nvPr/>
+        </p:nvSpPr>
+        <p:spPr>
+          <a:xfrm>
+            <a:off x="7543800" y="3840480"/>
+            <a:ext cx="1005840" cy="384048"/>
+          </a:xfrm>
+          <a:prstGeom prst="rect">
+            <a:avLst/>
+          </a:prstGeom>
+          <a:solidFill>
+            <a:srgbClr val="0A2800"/>
+          </a:solidFill>
+          <a:ln w="12700">
+            <a:solidFill>
+              <a:srgbClr val="2A2A2A"/>
+            </a:solidFill>
+            <a:prstDash val="solid"/>
+          </a:ln>
+        </p:spPr>
+      </p:sp>
+      <p:sp>
+        <p:nvSpPr>
+          <p:cNvPr id="111" name="Text 109"/>
+          <p:cNvSpPr txBox="1"/>
+          <p:nvPr/>
+        </p:nvSpPr>
+        <p:spPr>
+          <a:xfrm>
+            <a:off x="7598664" y="3858768"/>
+            <a:ext cx="914400" cy="347472"/>
+          </a:xfrm>
+          <a:prstGeom prst="rect">
+            <a:avLst/>
+          </a:prstGeom>
+          <a:noFill/>
+          <a:ln/>
+        </p:spPr>
+        <p:txBody>
+          <a:bodyPr wrap="square" rtlCol="0" anchor="ctr"/>
+          <a:lstStyle/>
+          <a:p>
+            <a:pPr algn="ctr" indent="0" marL="0">
+              <a:buNone/>
+            </a:pPr>
+            <a:r>
+              <a:rPr lang="en-US" sz="1100" b="1" dirty="0">
+                <a:solidFill>
+                  <a:srgbClr val="2ECC71"/>
+                </a:solidFill>
+              </a:rPr>
+              <a:t>5-yr total</a:t>
+            </a:r>
+            <a:endParaRPr lang="en-US" sz="1100" dirty="0"/>
           </a:p>
         </p:txBody>
       </p:sp>
       <p:pic>
         <p:nvPicPr>
-          <p:cNvPr id="70" name="Image 0" descr="/Users/exomac/.openclaw/workspace/drafts/_exos_white_official.png">    </p:cNvPr>
+          <p:cNvPr id="112" name="Image 0" descr="/Users/exomac/.openclaw/workspace/drafts/_exos_white_official.png">    </p:cNvPr>
           <p:cNvPicPr>
             <a:picLocks noChangeAspect="1"/>
           </p:cNvPicPr>
@@ -6064,7 +7491,7 @@
       </p:pic>
       <p:sp>
         <p:nvSpPr>
-          <p:cNvPr id="71" name="Text 68"/>
+          <p:cNvPr id="113" name="Text 110"/>
           <p:cNvSpPr txBox="1"/>
           <p:nvPr/>
         </p:nvSpPr>
@@ -6100,7 +7527,7 @@
       </p:sp>
       <p:sp>
         <p:nvSpPr>
-          <p:cNvPr id="72" name="Text 69"/>
+          <p:cNvPr id="114" name="Text 111"/>
           <p:cNvSpPr txBox="1"/>
           <p:nvPr/>
         </p:nvSpPr>

</xml_diff>